<commit_message>
docs: make 1–3강 speaker notes TTS-ready and export per-slide scripts
- remove instructor stage directions (timing, hand-raising, room checks), turn
  conditional Q&A cues into spoken sentences, normalize →/·/①/~ for TTS
- add data/생성형 AI 소프트웨어공학/대본/N강/NN.txt and N강_전체대본.txt

Co-Authored-By: Claude Fable 5 <noreply@anthropic.com>
</commit_message>
<xml_diff>
--- a/data/생성형 AI 소프트웨어공학/생성형AI소프트웨어공학_1강.pptx
+++ b/data/생성형 AI 소프트웨어공학/생성형AI소프트웨어공학_1강.pptx
@@ -537,13 +537,6 @@
           <a:p>
             <a:r>
               <a:rPr lang="ko-KR"/>
-              <a:t>(학생들이 자리 잡는 동안 이 화면을 띄워 두고, 정시에 시작합니다.)</a:t>
-            </a:r>
-          </a:p>
-          <a:p/>
-          <a:p>
-            <a:r>
-              <a:rPr lang="ko-KR"/>
               <a:t>안녕하세요. '생성형 AI 소프트웨어공학' 첫 시간입니다. 이 과목을 맡은 컴퓨터공학과 박상돈입니다. 반갑습니다.</a:t>
             </a:r>
           </a:p>
@@ -694,7 +687,7 @@
           <a:p>
             <a:r>
               <a:rPr lang="ko-KR"/>
-              <a:t>수업이 끝날 때 이 세 문장에 스스로 "할 수 있다"라고 답할 수 있으면 오늘 목표 달성입니다. 특히 세 번째, GitHub에 파일 올리기는 오늘 강의실을 나가기 전에 전원이 완료하는 게 목표입니다. 중간에 막히면 그냥 손 드세요. 환경 설치는 원래 다 같이 헤매면서 하는 겁니다. 잘 안 되는 게 여러분 잘못이 아닙니다.</a:t>
+              <a:t>수업이 끝날 때 이 세 문장에 스스로 "할 수 있다"라고 답할 수 있으면 오늘 목표 달성입니다. 특히 세 번째, GitHub에 파일 올리기는 오늘 강의실을 나가기 전에 전원이 완료하는 게 목표입니다. 중간에 막히면 질문하세요. 환경 설치는 원래 다 같이 헤매면서 하는 겁니다. 잘 안 되는 게 여러분 잘못이 아닙니다.</a:t>
             </a:r>
           </a:p>
         </p:txBody>
@@ -791,13 +784,6 @@
               <a:t>보통 첫 시간 오리엔테이션은 강의계획서를 같이 훑는 시간이라 지루하게 느껴질 수 있는데, 이 수업은 다른 과목과 전제가 다릅니다. 다른 수업에서는 AI를 쓰면 안 되는 경우가 많지만, 여기서는 AI를 쓰는 것이 기본입니다. 그래서 특히 뒤에 나오는 'AI 활용 규칙' 부분은 집중해서 들어 주세요. 여기서 합의한 규칙이 한 학기 내내 과제와 시험의 기준이 됩니다.</a:t>
             </a:r>
           </a:p>
-          <a:p/>
-          <a:p>
-            <a:r>
-              <a:rPr lang="ko-KR"/>
-              <a:t>(약 15분 예상. 질문은 그때그때 받습니다.)</a:t>
-            </a:r>
-          </a:p>
         </p:txBody>
       </p:sp>
       <p:sp>
@@ -1147,14 +1133,14 @@
           <a:p>
             <a:r>
               <a:rPr lang="ko-KR"/>
-              <a:t>전반부, 1주부터 7주까지는 '기초와 언어'입니다. 1~2주차에 환경을 만듭니다. 오늘 Python·VS Code·Git·GitHub를 깔고, 다음 주에 AI를 연결합니다. 3~4주차에는 생성형 AI가 어떻게 동작하는지 이해하고, AI에게 지시하는 글('지시문' 또는 '프롬프트'라고 부릅니다)을 잘 쓰는 법을 배웁니다. 5주차 요구사항 정의, 6주차 설계, 7주차에는 명세를 기반으로 AI에게 지시해서 기능을 받아내는 것까지 갑니다. 8주차 중간고사는 이 전반부가 범위입니다.</a:t>
+              <a:t>전반부, 1주부터 7주까지는 '기초와 언어'입니다. 1에서 2주차에 환경을 만듭니다. 오늘 Python, VS Code, Git, GitHub를 깔고, 다음 주에 AI를 연결합니다. 3에서 4주차에는 생성형 AI가 어떻게 동작하는지 이해하고, AI에게 지시하는 글('지시문' 또는 '프롬프트'라고 부릅니다)을 잘 쓰는 법을 배웁니다. 5주차 요구사항 정의, 6주차 설계, 7주차에는 명세를 기반으로 AI에게 지시해서 기능을 받아내는 것까지 갑니다. 8주차 중간고사는 이 전반부가 범위입니다.</a:t>
             </a:r>
           </a:p>
           <a:p/>
           <a:p>
             <a:r>
               <a:rPr lang="ko-KR"/>
-              <a:t>후반부, 9주부터 13주는 '품질과 운영'입니다. 만든 걸 어떻게 믿을 수 있게 만드느냐의 문제입니다. 9주차 테스트 설계, 10주차 결함 수정과 유지보수, 11주차 배포와 지속적 통합. 배포는 만든 프로그램을 실제 인터넷에 올려서 남들이 쓸 수 있게 하는 것, 지속적 통합은 그 과정을 자동화하는 것입니다. 12주차 코딩 에이전트 자동화, 13주차에 품질·보안·윤리를 다룹니다.</a:t>
+              <a:t>후반부, 9주부터 13주는 '품질과 운영'입니다. 만든 걸 어떻게 믿을 수 있게 만드느냐의 문제입니다. 9주차 테스트 설계, 10주차 결함 수정과 유지보수, 11주차 배포와 지속적 통합. 배포는 만든 프로그램을 실제 인터넷에 올려서 남들이 쓸 수 있게 하는 것, 지속적 통합은 그 과정을 자동화하는 것입니다. 12주차 코딩 에이전트 자동화, 13주차에 품질, 보안, 윤리를 다룹니다.</a:t>
             </a:r>
           </a:p>
           <a:p/>
@@ -1169,13 +1155,6 @@
             <a:r>
               <a:rPr lang="ko-KR"/>
               <a:t>아래 박스가 과제와 팀 프로젝트 일정입니다. 개인 과제는 3주, 7주, 9주에 세 번 나갑니다. 팀 프로젝트는 5주차에 주제를 정해서 학기 내내 조금씩 키우고, 14주차에 시연합니다. 그러니까 4주차까지는 개인 훈련 기간이고, 5주차부터는 팀으로도 움직인다고 기억해 두세요.</a:t>
-            </a:r>
-          </a:p>
-          <a:p/>
-          <a:p>
-            <a:r>
-              <a:rPr lang="ko-KR"/>
-              <a:t>(질문이 있으면 받고, 없으면 넘어갑니다.)</a:t>
             </a:r>
           </a:p>
         </p:txBody>
@@ -1297,7 +1276,7 @@
           <a:p>
             <a:r>
               <a:rPr lang="ko-KR"/>
-              <a:t>(노트북 사양 질문이 나오면: 최근 5년 안에 나온 노트북이면 충분합니다. 우리가 쓰는 AI는 인터넷 너머 구글 서버에서 돌기 때문에 노트북 성능은 크게 상관없습니다. 인터넷만 되면 됩니다.)</a:t>
+              <a:t>노트북 사양이 걱정될 수 있는데, 최근 5년 안에 나온 노트북이면 충분합니다. 우리가 쓰는 AI는 인터넷 너머 서버에서 돌기 때문에 노트북 성능은 크게 상관없습니다. 인터넷만 되면 됩니다.</a:t>
             </a:r>
           </a:p>
         </p:txBody>
@@ -1391,14 +1370,14 @@
           <a:p>
             <a:r>
               <a:rPr lang="ko-KR"/>
-              <a:t>먼저 시험이 두 번입니다. 중간고사 25퍼센트, 기말고사 25퍼센트로 합쳐서 50퍼센트입니다. 중간고사는 8주차에 1~7주 범위, 기말은 학기 말에 전 범위입니다. 두 시험 모두 AI 도구 없이 봅니다. 문제는 개념을 묻는 문항에 더해서, "이 상황에서 요구사항을 어떻게 정리하겠는가" 같은 판단 서술형이 나옵니다. 외운 것을 쓰는 시험이 아니라 판단력을 보는 시험이라고 생각하시면 됩니다.</a:t>
+              <a:t>먼저 시험이 두 번입니다. 중간고사 25퍼센트, 기말고사 25퍼센트로 합쳐서 50퍼센트입니다. 중간고사는 8주차에 1에서 7주 범위, 기말은 학기 말에 전 범위입니다. 두 시험 모두 AI 도구 없이 봅니다. 문제는 개념을 묻는 문항에 더해서, "이 상황에서 요구사항을 어떻게 정리하겠는가" 같은 판단 서술형이 나옵니다. 외운 것을 쓰는 시험이 아니라 판단력을 보는 시험이라고 생각하시면 됩니다.</a:t>
             </a:r>
           </a:p>
           <a:p/>
           <a:p>
             <a:r>
               <a:rPr lang="ko-KR"/>
-              <a:t>과제는 10퍼센트, 3주·7주·9주에 세 번 나갑니다.</a:t>
+              <a:t>과제는 10퍼센트, 3주, 7주, 9주에 세 번 나갑니다.</a:t>
             </a:r>
           </a:p>
           <a:p/>
@@ -1426,7 +1405,7 @@
           <a:p>
             <a:r>
               <a:rPr lang="ko-KR"/>
-              <a:t>지각·결석 처리, 제출 기한 같은 세부 규정은 이 슬라이드가 아니라 LMS에 있는 강의계획서 원문이 기준입니다. 꼭 한 번 읽어 두세요.</a:t>
+              <a:t>지각, 결석 처리, 제출 기한 같은 세부 규정은 이 슬라이드가 아니라 LMS에 있는 강의계획서 원문이 기준입니다. 꼭 한 번 읽어 두세요.</a:t>
             </a:r>
           </a:p>
         </p:txBody>
@@ -1534,7 +1513,7 @@
           <a:p>
             <a:r>
               <a:rPr lang="ko-KR"/>
-              <a:t>셋째, 중간·기말 두 번의 시험만은 AI 없이 봅니다. 도구는 빌릴 수 있지만 판단력은 빌릴 수 없기 때문입니다. 개념과 판단력은 본인 머리에 있어야 하고, 그것이 이 수업이 기르려는 능력입니다.</a:t>
+              <a:t>셋째, 중간, 기말 두 번의 시험만은 AI 없이 봅니다. 도구는 빌릴 수 있지만 판단력은 빌릴 수 없기 때문입니다. 개념과 판단력은 본인 머리에 있어야 하고, 그것이 이 수업이 기르려는 능력입니다.</a:t>
             </a:r>
           </a:p>
           <a:p/>
@@ -1548,7 +1527,7 @@
           <a:p>
             <a:r>
               <a:rPr lang="ko-KR"/>
-              <a:t>(여기서 잠깐 멈추고 질문을 받습니다. "친구 코드를 AI로 고쳐서 내면요?" 같은 질문이 나오면: 설명할 수 있느냐가 기준이라고 다시 강조합니다.)</a:t>
+              <a:t>"친구 코드를 AI로 고쳐서 내면요?"라는 질문이 나올 수 있는데, 기준은 똑같습니다. 설명할 수 있느냐입니다.</a:t>
             </a:r>
           </a:p>
         </p:txBody>
@@ -1645,13 +1624,6 @@
               <a:t>사람이 다치고, 로켓이 터지고, 회사가 무너진 사건들인데, 셋 다 원인이 "코딩 실력 부족"이 아니었다는 게 핵심입니다. 이걸 먼저 보고 나면 왜 '공학'이라는 말이 붙는지 훨씬 잘 이해됩니다.</a:t>
             </a:r>
           </a:p>
-          <a:p/>
-          <a:p>
-            <a:r>
-              <a:rPr lang="ko-KR"/>
-              <a:t>(약 25분 예상.)</a:t>
-            </a:r>
-          </a:p>
         </p:txBody>
       </p:sp>
       <p:sp>
@@ -1736,7 +1708,7 @@
           <a:p>
             <a:r>
               <a:rPr lang="ko-KR"/>
-              <a:t>정의부터 보겠습니다. IEEE라는 국제 전기전자공학회의 고전적인 정의를 우리말로 풀면 이렇습니다. "소프트웨어의 개발·운영·유지보수에 체계적이고, 규율 있으며, 측정 가능한 접근을 적용하는 것."</a:t>
+              <a:t>정의부터 보겠습니다. IEEE라는 국제 전기전자공학회의 고전적인 정의를 우리말로 풀면 이렇습니다. "소프트웨어의 개발, 운영, 유지보수에 체계적이고, 규율 있으며, 측정 가능한 접근을 적용하는 것."</a:t>
             </a:r>
           </a:p>
           <a:p/>
@@ -1893,14 +1865,14 @@
           <a:p>
             <a:r>
               <a:rPr lang="ko-KR"/>
-              <a:t>(학생들에게 질문) 자, 셋의 공통점이 뭘까요? 코딩을 못해서가 아니라는 건 분명하죠. Therac-25 개발자도, Ariane 개발자도, Knight 개발자도 뛰어난 사람들이었습니다. 잠깐 옆 사람과 30초만 얘기해 보고, 다음 장에서 정리하겠습니다.</a:t>
+              <a:t>자, 셋의 공통점이 뭘까요? 코딩을 못해서가 아니라는 건 분명하죠. Therac-25 개발자도, Ariane 개발자도, Knight 개발자도 뛰어난 사람들이었습니다. 잠깐 옆 사람과 30초만 얘기해 보고, 다음 장에서 정리하겠습니다.</a:t>
             </a:r>
           </a:p>
           <a:p/>
           <a:p>
             <a:r>
               <a:rPr lang="ko-KR"/>
-              <a:t>(30초 정도 기다렸다가 두어 명 답을 듣습니다. "확인을 안 했다", "테스트를 안 했다" 같은 답이 나오면 좋은 답이라고 받아 줍니다.)</a:t>
+              <a:t>"확인을 안 했다", "테스트를 안 했다" 같은 답이 떠올랐다면 좋은 답입니다.</a:t>
             </a:r>
           </a:p>
         </p:txBody>
@@ -2238,7 +2210,7 @@
           <a:p>
             <a:r>
               <a:rPr lang="ko-KR"/>
-              <a:t>(2~3명 답을 들어 봅니다. "사라진다", "줄어든다", "역할이 바뀐다" 등 어떤 답이든 받아 주고, 왜 그렇게 생각하는지 한 마디씩 더 물어봅니다.)</a:t>
+              <a:t>"사라진다", "줄어든다", "역할이 바뀐다", 어떤 답이든 좋습니다. 왜 그렇게 생각하는지까지 한 번 떠올려 보세요.</a:t>
             </a:r>
           </a:p>
           <a:p/>
@@ -2367,21 +2339,21 @@
           <a:p>
             <a:r>
               <a:rPr lang="ko-KR"/>
-              <a:t>셋째, "됐다"의 기준을 세운다. 결과물을 받았을 때 통과인지 불통과인지 판정할 기준을 미리 정하는 일입니다. 이걸 '인수 조건'이라고 부릅니다. 기준이 없으면 AI가 "다 됐습니다"라고 할 때 그냥 믿을 수밖에 없죠. 8·9주차입니다.</a:t>
+              <a:t>셋째, "됐다"의 기준을 세운다. 결과물을 받았을 때 통과인지 불통과인지 판정할 기준을 미리 정하는 일입니다. 이걸 '인수 조건'이라고 부릅니다. 기준이 없으면 AI가 "다 됐습니다"라고 할 때 그냥 믿을 수밖에 없죠. 8, 9주차입니다.</a:t>
             </a:r>
           </a:p>
           <a:p/>
           <a:p>
             <a:r>
               <a:rPr lang="ko-KR"/>
-              <a:t>넷째, 정말 되는지 검증한다. 테스트를 설계하고, 통과했는데도 남아 있는 결함을 찾아내는 눈입니다. Therac-25처럼 테스트를 통과하고도 사고가 나는 경우가 있으니까요. 9·10주차입니다.</a:t>
+              <a:t>넷째, 정말 되는지 검증한다. 테스트를 설계하고, 통과했는데도 남아 있는 결함을 찾아내는 눈입니다. Therac-25처럼 테스트를 통과하고도 사고가 나는 경우가 있으니까요. 9, 10주차입니다.</a:t>
             </a:r>
           </a:p>
           <a:p/>
           <a:p>
             <a:r>
               <a:rPr lang="ko-KR"/>
-              <a:t>다섯째, 품질·보안·윤리에 책임진다. AI가 만든 코드에 보안 구멍이 있거나, 남의 코드를 허락 없이 베낀 것이거나, 개인정보를 잘못 다루더라도, 최종 책임은 이름을 올린 사람에게 있습니다. 13주차입니다.</a:t>
+              <a:t>다섯째, 품질, 보안, 윤리에 책임진다. AI가 만든 코드에 보안 구멍이 있거나, 남의 코드를 허락 없이 베낀 것이거나, 개인정보를 잘못 다루더라도, 최종 책임은 이름을 올린 사람에게 있습니다. 13주차입니다.</a:t>
             </a:r>
           </a:p>
           <a:p/>
@@ -2475,14 +2447,14 @@
           <a:p>
             <a:r>
               <a:rPr lang="ko-KR"/>
-              <a:t>과목 구조를 '생명주기' 위에 얹어 보겠습니다. 생명주기라는 말은 소프트웨어가 태어나서 운영되기까지의 여정을 뜻합니다. 사람에게 출생·성장·노년이 있듯이, 소프트웨어도 정해진 흐름이 있습니다.</a:t>
+              <a:t>과목 구조를 '생명주기' 위에 얹어 보겠습니다. 생명주기라는 말은 소프트웨어가 태어나서 운영되기까지의 여정을 뜻합니다. 사람에게 출생, 성장, 노년이 있듯이, 소프트웨어도 정해진 흐름이 있습니다.</a:t>
             </a:r>
           </a:p>
           <a:p/>
           <a:p>
             <a:r>
               <a:rPr lang="ko-KR"/>
-              <a:t>화면의 여섯 칸을 왼쪽부터 보세요. 요구, 무엇을 만들까 (5주). 설계, 어떤 구조로 (6주). 구현·지시, AI에게 맡겨 받아내기 (7주). 검증, 테스트 설계 (9주). 유지보수, 결함 재현과 수정 (10주). 배포·자동화, CI/CD와 에이전트 (11~12주). 우리 수업 5주차부터 12주차가 정확히 이 순서입니다.</a:t>
+              <a:t>화면의 여섯 칸을 왼쪽부터 보세요. 요구, 무엇을 만들까 (5주). 설계, 어떤 구조로 (6주). 구현, 지시, AI에게 맡겨 받아내기 (7주). 검증, 테스트 설계 (9주). 유지보수, 결함 재현과 수정 (10주). 배포, 자동화, CI/CD와 에이전트 (11에서 12주). 우리 수업 5주차부터 12주차가 정확히 이 순서입니다.</a:t>
             </a:r>
           </a:p>
           <a:p/>
@@ -2504,13 +2476,6 @@
             <a:r>
               <a:rPr lang="ko-KR"/>
               <a:t>자, 개념 얘기는 여기까지 하고, 이제 진짜로 장비를 갖추러 갑시다. 노트북 여세요. 충전기 꽂고, 와이파이 연결하세요.</a:t>
-            </a:r>
-          </a:p>
-          <a:p/>
-          <a:p>
-            <a:r>
-              <a:rPr lang="ko-KR"/>
-              <a:t>(여기서 5분 쉬어 갑니다. 쉬는 동안 와이파이 연결을 확인하게 합니다.)</a:t>
             </a:r>
           </a:p>
         </p:txBody>
@@ -2604,7 +2569,7 @@
           <a:p>
             <a:r>
               <a:rPr lang="ko-KR"/>
-              <a:t>진행 방식을 먼저 말씀드립니다. 각 단계마다 슬라이드에 실제 사이트 화면을 캡처해서 넣어 뒀고, 어디를 눌러야 하는지 빨간 네모와 번호로 표시해 뒀습니다. 그리고 각 단계 끝에는 '확인 명령'이나 '통과 기준'이 있습니다. 확인이 안 되면 다음으로 넘어가지 말고 바로 손 드세요. 뒤 단계는 앞 단계 위에서 돌아가기 때문에, 앞에서 막힌 채 넘어가면 나중에 더 꼬입니다.</a:t>
+              <a:t>진행 방식을 먼저 말씀드립니다. 각 단계마다 슬라이드에 실제 사이트 화면을 캡처해서 넣어 뒀고, 어디를 눌러야 하는지 빨간 네모와 번호로 표시해 뒀습니다. 그리고 각 단계 끝에는 '확인 명령'이나 '통과 기준'이 있습니다. 확인이 안 되면 다음으로 넘어가지 말고 바로 질문하세요. 뒤 단계는 앞 단계 위에서 돌아가기 때문에, 앞에서 막힌 채 넘어가면 나중에 더 꼬입니다.</a:t>
             </a:r>
           </a:p>
           <a:p/>
@@ -2625,7 +2590,7 @@
           <a:p>
             <a:r>
               <a:rPr lang="ko-KR"/>
-              <a:t>(약 80~90분 예상. 설치 대기 시간이 많으니, 다운로드가 느린 사람은 먼저 다음 단계 설치 파일을 받아 두게 합니다.)</a:t>
+              <a:t>설치 대기 시간이 많으니, 다운로드가 느리면 먼저 다음 단계 설치 파일을 받아 두어도 됩니다.</a:t>
             </a:r>
           </a:p>
         </p:txBody>
@@ -2848,7 +2813,7 @@
           <a:p>
             <a:r>
               <a:rPr lang="ko-KR"/>
-              <a:t>여는 법입니다. Windows에서 키보드 왼쪽 아래 창문 모양 키, Win 키를 누르면 검색창이 뜹니다. 거기에 c, m, d 세 글자를 치고 Enter. 그러면 검은 창이 하나 뜹니다. 그게 명령 프롬프트입니다. 다들 한번 열어 보세요. (30초 기다립니다.) 검은 창 뜬 사람 손 들어 보세요. 안 뜬 사람은 Win 키 누르고 '터미널'이라고 한글로 쳐도 됩니다.</a:t>
+              <a:t>여는 법입니다. Windows에서 키보드 왼쪽 아래 창문 모양 키, Win 키를 누르면 검색창이 뜹니다. 거기에 c, m, d 세 글자를 치고 Enter. 그러면 검은 창이 하나 뜹니다. 그게 명령 프롬프트입니다. 다들 한번 열어 보세요. 검은 창이 안 뜨면 Win 키 누르고 '터미널'이라고 한글로 쳐도 됩니다.</a:t>
             </a:r>
           </a:p>
           <a:p/>
@@ -2862,7 +2827,7 @@
           <a:p>
             <a:r>
               <a:rPr lang="ko-KR"/>
-              <a:t>'먹는다, 안 먹는다'라는 표현을 오늘 계속 쓸 겁니다. 명령을 쳤을 때 결과가 나오면 "먹는다", 대신 "'python'은(는) 내부 또는 외부 명령, 실행할 수 있는 프로그램, 또는 배치 파일이 아닙니다" 같은 문장이 나오면 "안 먹는다"입니다. 안 먹는다는 건 컴퓨터가 그 프로그램을 못 찾는다는 뜻이고, 오늘 그런 경우 대부분은 설치가 안 됐거나 PATH 설정이 빠진 겁니다. 안 먹으면 손 드세요.</a:t>
+              <a:t>'먹는다, 안 먹는다'라는 표현을 오늘 계속 쓸 겁니다. 명령을 쳤을 때 결과가 나오면 "먹는다", 대신 "'python'은(는) 내부 또는 외부 명령, 실행할 수 있는 프로그램, 또는 배치 파일이 아닙니다" 같은 문장이 나오면 "안 먹는다"입니다. 안 먹는다는 건 컴퓨터가 그 프로그램을 못 찾는다는 뜻이고, 오늘 그런 경우 대부분은 설치가 안 됐거나 PATH 설정이 빠진 겁니다. 안 먹으면 질문하세요.</a:t>
             </a:r>
           </a:p>
           <a:p/>
@@ -2876,7 +2841,7 @@
           <a:p>
             <a:r>
               <a:rPr lang="ko-KR"/>
-              <a:t>(질문: "Mac은요?" 하면, Mac은 Spotlight, 즉 Command+Space를 누르고 '터미널'을 치면 됩니다. Mac 사용자는 몇 명인지 손 들게 해서 파악해 둡니다.)</a:t>
+              <a:t>Mac이라면 Spotlight, 즉 Command+Space를 누르고 '터미널'을 치면 됩니다.</a:t>
             </a:r>
           </a:p>
         </p:txBody>
@@ -2961,42 +2926,42 @@
           <a:p>
             <a:r>
               <a:rPr lang="ko-KR"/>
-              <a:t>①번. 브라우저(크롬이든 엣지든)를 열고 맨 위 주소창에 python.org/downloads 를 입력하고 Enter. 그러면 왼쪽 화면이 나옵니다. Windows에서 접속하면 자동으로 "Download the latest version for Windows"라고 Windows용 화면이 나옵니다.</a:t>
+              <a:t>1번. 브라우저(크롬이든 엣지든)를 열고 맨 위 주소창에 python.org/downloads 를 입력하고 Enter. 그러면 왼쪽 화면이 나옵니다. Windows에서 접속하면 자동으로 "Download the latest version for Windows"라고 Windows용 화면이 나옵니다.</a:t>
             </a:r>
           </a:p>
           <a:p/>
           <a:p>
             <a:r>
               <a:rPr lang="ko-KR"/>
-              <a:t>②번, 여기가 오늘의 첫 번째 함정입니다. 화면에 노란 큰 버튼이 있죠, "Download Python install manager". 이걸 누르고 싶은 마음이 들지만 오늘은 누르지 않습니다. 이건 'install manager'라는, 파이썬을 관리해 주는 별도의 프로그램입니다. 2025년쯤부터 새로 생긴 건데, 우리 수업은 전통적인 설치 방식으로 통일합니다. 이유는 간단합니다. 인터넷에 있는 거의 모든 안내 자료와 이 강의 자료가 전통 방식 기준이라, 문제가 생겼을 때 검색해서 해결하기가 훨씬 쉽기 때문입니다.</a:t>
+              <a:t>2번, 여기가 오늘의 첫 번째 함정입니다. 화면에 노란 큰 버튼이 있죠, "Download Python install manager". 이걸 누르고 싶은 마음이 들지만 오늘은 누르지 않습니다. 이건 'install manager'라는, 파이썬을 관리해 주는 별도의 프로그램입니다. 2025년쯤부터 새로 생긴 건데, 우리 수업은 전통적인 설치 방식으로 통일합니다. 이유는 간단합니다. 인터넷에 있는 거의 모든 안내 자료와 이 강의 자료가 전통 방식 기준이라, 문제가 생겼을 때 검색해서 해결하기가 훨씬 쉽기 때문입니다.</a:t>
             </a:r>
           </a:p>
           <a:p/>
           <a:p>
             <a:r>
               <a:rPr lang="ko-KR"/>
-              <a:t>우리가 누를 것은 노란 버튼 바로 아래 문장입니다. "Or get the standalone installer for Python 3.14.7", 여기서 파란색 "Python 3.14.7" 링크. 슬라이드에 빨간 네모 ①번으로 표시해 뒀습니다. 이걸 클릭하면 python-3.14.7-amd64.exe 라는 파일이 내려받아집니다. 'standalone installer'는 '독립 설치 파일'이라는 뜻입니다.</a:t>
+              <a:t>우리가 누를 것은 노란 버튼 바로 아래 문장입니다. "Or get the standalone installer for Python 3.14.7", 여기서 파란색 "Python 3.14.7" 링크. 슬라이드에 빨간 네모 1번으로 표시해 뒀습니다. 이걸 클릭하면 python-3.14.7-amd64.exe 라는 파일이 내려받아집니다. 'standalone installer'는 '독립 설치 파일'이라는 뜻입니다.</a:t>
             </a:r>
           </a:p>
           <a:p/>
           <a:p>
             <a:r>
               <a:rPr lang="ko-KR"/>
-              <a:t>③번. 내려받은 파일을 실행합니다. 브라우저 오른쪽 위 다운로드 아이콘을 눌러도 되고, 파일 탐색기의 '다운로드' 폴더에 가도 됩니다. python-3.14.7-amd64.exe 를 더블클릭하면 설치 화면이 뜹니다. 그 화면은 다음 장에서 봅니다. 아직 아무것도 누르지 말고 다음 장 보고 누르세요.</a:t>
+              <a:t>3번. 내려받은 파일을 실행합니다. 브라우저 오른쪽 위 다운로드 아이콘을 눌러도 되고, 파일 탐색기의 '다운로드' 폴더에 가도 됩니다. python-3.14.7-amd64.exe 를 더블클릭하면 설치 화면이 뜹니다. 그 화면은 다음 장에서 봅니다. 아직 아무것도 누르지 말고 다음 장 보고 누르세요.</a:t>
             </a:r>
           </a:p>
           <a:p/>
           <a:p>
             <a:r>
               <a:rPr lang="ko-KR"/>
-              <a:t>아래 노란 박스, 자주 나오는 질문입니다. "슬라이드에는 3.14.7인데 제 화면은 3.14.8이에요" 하는 질문이 나올 텐데, 괜찮습니다. 날짜에 따라 숫자가 바뀝니다. 3.11 이상이면 무엇이든 됩니다. Mac 사용자는 같은 화면에서 'macOS' 링크로 들어가서 .pkg 파일을 받아 설치하면 되고, Mac은 다음 장에 나오는 PATH 체크가 없어서 그냥 계속 '계속' 버튼만 누르면 됩니다.</a:t>
+              <a:t>아래 노란 박스, 자주 나오는 질문입니다. "슬라이드에는 3.14.7인데 제 화면은 3.14.8이에요" 하는 질문이 나올 텐데, 괜찮습니다. 날짜에 따라 숫자가 바뀝니다. 3.11 이상이면 무엇이든 됩니다. Mac 사용자는 같은 화면에서 'macOS' 링크로 들어가서.pkg 파일을 받아 설치하면 되고, Mac은 다음 장에 나오는 PATH 체크가 없어서 그냥 계속 '계속' 버튼만 누르면 됩니다.</a:t>
             </a:r>
           </a:p>
           <a:p/>
           <a:p>
             <a:r>
               <a:rPr lang="ko-KR"/>
-              <a:t>(다운로드에 1~2분 걸립니다. 그동안 교실을 한 바퀴 돌면서 노란 버튼을 누른 사람이 없는지 확인합니다. 눌렀다면 그냥 그 파일은 무시하고 링크를 다시 누르게 합니다.)</a:t>
+              <a:t>다운로드에 1, 2분 걸립니다. 노란 버튼을 눌렀다면 그 파일은 무시하고 링크를 다시 누르면 됩니다.</a:t>
             </a:r>
           </a:p>
         </p:txBody>
@@ -3081,21 +3046,21 @@
           <a:p>
             <a:r>
               <a:rPr lang="ko-KR"/>
-              <a:t>①번, 맨 아래 "Add python.exe to PATH" 체크박스를 먼저 켭니다. 이게 오늘 실습에서 가장 많이 놓치는 지점입니다. 매 학기 이거 하나 때문에 수십 분씩 잡아먹습니다. PATH가 뭐냐면, 컴퓨터가 "python이라는 명령이 들어오면 어디 있는 프로그램을 실행할지"를 적어 둔 주소록 같은 것입니다. 이 체크를 켜야 그 주소록에 파이썬이 등록돼서, 어느 폴더에서든 python 명령이 '먹습니다'. 안 켜면 설치는 되는데 터미널에서 python을 쳐도 못 찾습니다.</a:t>
+              <a:t>1번, 맨 아래 "Add python.exe to PATH" 체크박스를 먼저 켭니다. 이게 오늘 실습에서 가장 많이 놓치는 지점입니다. 매 학기 이거 하나 때문에 수십 분씩 잡아먹습니다. PATH가 뭐냐면, 컴퓨터가 "python이라는 명령이 들어오면 어디 있는 프로그램을 실행할지"를 적어 둔 주소록 같은 것입니다. 이 체크를 켜야 그 주소록에 파이썬이 등록돼서, 어느 폴더에서든 python 명령이 '먹습니다'. 안 켜면 설치는 되는데 터미널에서 python을 쳐도 못 찾습니다.</a:t>
             </a:r>
           </a:p>
           <a:p/>
           <a:p>
             <a:r>
               <a:rPr lang="ko-KR"/>
-              <a:t>②번, 그다음에 "Install Now"를 클릭합니다. 1~2분 정도 진행 표시가 지나가고 "Setup was successful"이라고 뜨면 Close를 누르면 끝입니다. 중간에 "이 앱이 디바이스를 변경할 수 있도록 허용하시겠어요?" 창이 뜨면 '예'입니다.</a:t>
+              <a:t>2번, 그다음에 "Install Now"를 클릭합니다. 1에서 2분 정도 진행 표시가 지나가고 "Setup was successful"이라고 뜨면 Close를 누르면 끝입니다. 중간에 "이 앱이 디바이스를 변경할 수 있도록 허용하시겠어요?" 창이 뜨면 '예'입니다.</a:t>
             </a:r>
           </a:p>
           <a:p/>
           <a:p>
             <a:r>
               <a:rPr lang="ko-KR"/>
-              <a:t>다 됐으면 확인합니다. 오른쪽 검은 박스입니다. 중요한 건 터미널을 '새로' 여는 것입니다. 설치 전에 열어 둔 터미널은 새 프로그램을 모릅니다. 아까 연 명령 프롬프트 창을 닫고, Win 키 → cmd → Enter로 새로 여세요. 그리고 python --version 을 칩니다. python 띄고 하이픈 두 개 version. "Python 3.14.7"처럼 버전 숫자가 찍히면 성공입니다.</a:t>
+              <a:t>다 됐으면 확인합니다. 오른쪽 검은 박스입니다. 중요한 건 터미널을 '새로' 여는 것입니다. 설치 전에 열어 둔 터미널은 새 프로그램을 모릅니다. 아까 연 명령 프롬프트 창을 닫고, Win 키, cmd, Enter로 새로 여세요. 그리고 python --version 을 칩니다. python 띄고 하이픈 두 개 version. "Python 3.14.7"처럼 버전 숫자가 찍히면 성공입니다.</a:t>
             </a:r>
           </a:p>
           <a:p/>
@@ -3109,14 +3074,7 @@
           <a:p>
             <a:r>
               <a:rPr lang="ko-KR"/>
-              <a:t>오른쪽 아래 두 박스가 자주 생기는 문제입니다. PATH 체크를 놓치고 설치했다면 고민하지 말고 다시 설치하는 게 제일 빠릅니다. Windows 설정 → 앱 → 'Python 3.14' 찾아서 제거 → 아까 받은 설치 파일을 다시 실행해서 이번엔 체크하고 Install Now. 1분이면 됩니다. 그리고 python을 쳤는데 Microsoft Store가 열리는 경우가 있습니다. Windows가 "파이썬이 없으니 스토어에서 깔아라"고 안내하는 건데, 이것도 PATH가 안 잡힌 신호입니다. 재설치하거나, 일단 py --version 으로 확인하고 넘어가도 됩니다.</a:t>
-            </a:r>
-          </a:p>
-          <a:p/>
-          <a:p>
-            <a:r>
-              <a:rPr lang="ko-KR"/>
-              <a:t>(교실을 한 바퀴 돌며 버전 출력을 확인합니다. 전원 확인 전에는 다음으로 넘어가지 않습니다.)</a:t>
+              <a:t>오른쪽 아래 두 박스가 자주 생기는 문제입니다. PATH 체크를 놓치고 설치했다면 고민하지 말고 다시 설치하는 게 제일 빠릅니다. Windows 설정, 앱, 'Python 3.14' 찾아서 제거, 아까 받은 설치 파일을 다시 실행해서 이번엔 체크하고 Install Now. 1분이면 됩니다. 그리고 python을 쳤는데 Microsoft Store가 열리는 경우가 있습니다. Windows가 "파이썬이 없으니 스토어에서 깔아라"고 안내하는 건데, 이것도 PATH가 안 잡힌 신호입니다. 재설치하거나, 일단 py --version 으로 확인하고 넘어가도 됩니다.</a:t>
             </a:r>
           </a:p>
         </p:txBody>
@@ -3194,21 +3152,21 @@
           <a:p>
             <a:r>
               <a:rPr lang="ko-KR"/>
-              <a:t>①번. 브라우저 주소창에 code.visualstudio.com 을 입력합니다. 왼쪽 화면이 나오는데, 가운데 큰 검은 버튼 "Download for Windows"가 보이죠. 사이트가 여러분 컴퓨터의 운영체제를 알아서 감지해서 맞는 버튼을 보여 줍니다. Mac이면 "Download for macOS"라고 나옵니다. 그걸 누르면 VSCodeUserSetup-x64-1.xx.exe 같은 이름의 파일이 내려받아집니다.</a:t>
+              <a:t>1번. 브라우저 주소창에 code.visualstudio.com 을 입력합니다. 왼쪽 화면이 나오는데, 가운데 큰 검은 버튼 "Download for Windows"가 보이죠. 사이트가 여러분 컴퓨터의 운영체제를 알아서 감지해서 맞는 버튼을 보여 줍니다. Mac이면 "Download for macOS"라고 나옵니다. 그걸 누르면 VSCodeUserSetup-x64-1.xx.exe 같은 이름의 파일이 내려받아집니다.</a:t>
             </a:r>
           </a:p>
           <a:p/>
           <a:p>
             <a:r>
               <a:rPr lang="ko-KR"/>
-              <a:t>②번. 받은 파일을 실행하면 설치 마법사가 뜹니다. 첫 화면은 사용권 계약인데 "I accept the agreement"를 고르고 Next. 그다음부터 설치 위치, 시작 메뉴 폴더, 추가 작업 선택 화면이 차례로 나오는데 전부 기본값 그대로 Next만 누릅니다. 하나도 바꿀 필요 없습니다. 특히 '추가 작업' 화면에 "Add to PATH"라는 항목이 있는데 기본으로 체크돼 있으니 그대로 두면 됩니다. Install을 누르고 잠깐 기다린 뒤 Finish. 이때 "Launch Visual Studio Code" 체크가 켜져 있으면 Finish와 동시에 VS Code가 실행됩니다.</a:t>
+              <a:t>2번. 받은 파일을 실행하면 설치 마법사가 뜹니다. 첫 화면은 사용권 계약인데 "I accept the agreement"를 고르고 Next. 그다음부터 설치 위치, 시작 메뉴 폴더, 추가 작업 선택 화면이 차례로 나오는데 전부 기본값 그대로 Next만 누릅니다. 하나도 바꿀 필요 없습니다. 특히 '추가 작업' 화면에 "Add to PATH"라는 항목이 있는데 기본으로 체크돼 있으니 그대로 두면 됩니다. Install을 누르고 잠깐 기다린 뒤 Finish. 이때 "Launch Visual Studio Code" 체크가 켜져 있으면 Finish와 동시에 VS Code가 실행됩니다.</a:t>
             </a:r>
           </a:p>
           <a:p/>
           <a:p>
             <a:r>
               <a:rPr lang="ko-KR"/>
-              <a:t>③번. VS Code 창이 뜨면 이 단계 통과입니다. 처음엔 영어 화면이고, 환영 페이지가 뜹니다. 다음 장에서 한국어로 바꾸고 Python 확장을 설치합니다.</a:t>
+              <a:t>3번. VS Code 창이 뜨면 이 단계 통과입니다. 처음엔 영어 화면이고, 환영 페이지가 뜹니다. 다음 장에서 한국어로 바꾸고 Python 확장을 설치합니다.</a:t>
             </a:r>
           </a:p>
           <a:p/>
@@ -3222,7 +3180,7 @@
           <a:p>
             <a:r>
               <a:rPr lang="ko-KR"/>
-              <a:t>(다운로드와 설치에 2~3분. 이 사이에 앞 단계 못 끝낸 사람을 도와줍니다.)</a:t>
+              <a:t>다운로드와 설치에 2, 3분 걸립니다.</a:t>
             </a:r>
           </a:p>
         </p:txBody>
@@ -3300,42 +3258,42 @@
           <a:p>
             <a:r>
               <a:rPr lang="ko-KR"/>
-              <a:t>①번. VS Code 왼쪽에 세로로 아이콘이 늘어선 막대가 있습니다. 위에서부터 파일 두 장, 돋보기, 가지 모양, 재생 버튼, 그리고 네모 블록 네 개짜리 아이콘. 그 네모 블록 네 개가 '확장' 아이콘입니다. 슬라이드에 빨간 네모 ①번으로 표시해 뒀습니다. 그걸 클릭하세요. 단축키는 Ctrl+Shift+X 입니다. 클릭하면 왼쪽에 "Extensions: Marketplace"라는 패널이 열립니다. Marketplace, 확장을 고르는 장터입니다.</a:t>
+              <a:t>1번. VS Code 왼쪽에 세로로 아이콘이 늘어선 막대가 있습니다. 위에서부터 파일 두 장, 돋보기, 가지 모양, 재생 버튼, 그리고 네모 블록 네 개짜리 아이콘. 그 네모 블록 네 개가 '확장' 아이콘입니다. 슬라이드에 빨간 네모 1번으로 표시해 뒀습니다. 그걸 클릭하세요. 단축키는 Ctrl+Shift+X 입니다. 클릭하면 왼쪽에 "Extensions: Marketplace"라는 패널이 열립니다. Marketplace, 확장을 고르는 장터입니다.</a:t>
             </a:r>
           </a:p>
           <a:p/>
           <a:p>
             <a:r>
               <a:rPr lang="ko-KR"/>
-              <a:t>②번, 오른쪽 위 화면입니다. 패널 맨 위에 검색창이 있습니다. 거기에 Korean 이라고 칩니다. 그러면 결과가 쭉 나오는데, ③번, 맨 위에 "Korean Language Pack for Visual Studio Code", 제작자 Microsoft, 다운로드 690만 회짜리가 있습니다. 비슷한 이름이 여러 개 나오는데 Microsoft가 만든 것, 파란 체크 표시가 있는 것을 고르세요. 그 항목의 파란 "Install" 버튼을 클릭합니다.</a:t>
+              <a:t>2번, 오른쪽 위 화면입니다. 패널 맨 위에 검색창이 있습니다. 거기에 Korean 이라고 칩니다. 그러면 결과가 쭉 나오는데, 3번, 맨 위에 "Korean Language Pack for Visual Studio Code", 제작자 Microsoft, 다운로드 690만 회짜리가 있습니다. 비슷한 이름이 여러 개 나오는데 Microsoft가 만든 것, 파란 체크 표시가 있는 것을 고르세요. 그 항목의 파란 "Install" 버튼을 클릭합니다.</a:t>
             </a:r>
           </a:p>
           <a:p/>
           <a:p>
             <a:r>
               <a:rPr lang="ko-KR"/>
-              <a:t>④번, 왼쪽 아래 화면입니다. 설치가 끝나면 오른쪽 아래에 알림이 하나 뜹니다. "Would you like to change VS Code's UI language to Korean and restart?" 하고 "Change Language and Restart" 버튼. 그 버튼을 누르면 VS Code가 껐다 켜지면서 메뉴가 전부 한국어로 바뀝니다. 슬라이드 그림은 웹 버전이라 "Reload"라고 나오는데 같은 뜻입니다.</a:t>
+              <a:t>4번, 왼쪽 아래 화면입니다. 설치가 끝나면 오른쪽 아래에 알림이 하나 뜹니다. "Would you like to change VS Code's UI language to Korean and restart?" 하고 "Change Language and Restart" 버튼. 그 버튼을 누르면 VS Code가 껐다 켜지면서 메뉴가 전부 한국어로 바뀝니다. 슬라이드 그림은 웹 버전이라 "Reload"라고 나오는데 같은 뜻입니다.</a:t>
             </a:r>
           </a:p>
           <a:p/>
           <a:p>
             <a:r>
               <a:rPr lang="ko-KR"/>
-              <a:t>다시 켜졌을 때 위쪽 메뉴가 '파일 · 편집 · 선택 영역 · 보기 · 이동 · 실행 · 터미널 · 도움말'처럼 한국어로 보이면 성공입니다. 알림을 놓쳤거나 실수로 닫았으면 VS Code를 완전히 껐다가 다시 켜면 됩니다. 그래도 영어면 손 드세요.</a:t>
+              <a:t>다시 켜졌을 때 위쪽 메뉴가 '파일, 편집, 선택 영역, 보기, 이동, 실행, 터미널, 도움말'처럼 한국어로 보이면 성공입니다. 알림을 놓쳤거나 실수로 닫았으면 VS Code를 완전히 껐다가 다시 켜면 됩니다. 그래도 영어면 질문하세요.</a:t>
             </a:r>
           </a:p>
           <a:p/>
           <a:p>
             <a:r>
               <a:rPr lang="ko-KR"/>
-              <a:t>오른쪽 아래, 왜 한국어 팩부터 하느냐. 이후 슬라이드에서 메뉴 이름을 "터미널 → 새 터미널"처럼 한국어로 안내하기 때문입니다. 영어 그대로 쓰고 싶은 사람은 건너뛰어도 됩니다. 그 경우 슬라이드의 괄호 안 영어 이름을 보면 됩니다.</a:t>
+              <a:t>오른쪽 아래, 왜 한국어 팩부터 하느냐. 이후 슬라이드에서 메뉴 이름을 "터미널, 새 터미널"처럼 한국어로 안내하기 때문입니다. 영어 그대로 쓰고 싶은 사람은 건너뛰어도 됩니다. 그 경우 슬라이드의 괄호 안 영어 이름을 보면 됩니다.</a:t>
             </a:r>
           </a:p>
           <a:p/>
           <a:p>
             <a:r>
               <a:rPr lang="ko-KR"/>
-              <a:t>(30초~1분 소요. 한국어로 바뀐 사람 손 들게 해서 확인합니다.)</a:t>
+              <a:t>30초에서 1분 정도 걸립니다.</a:t>
             </a:r>
           </a:p>
         </p:txBody>
@@ -3413,42 +3371,42 @@
           <a:p>
             <a:r>
               <a:rPr lang="ko-KR"/>
-              <a:t>④번. 확장 패널의 검색창에 이번엔 Python 이라고 칩니다. 한국어 팩을 깔고 재시작했다면 패널 이름이 '확장: 마켓플레이스'로 바뀌어 있을 겁니다.</a:t>
+              <a:t>4번. 확장 패널의 검색창에 이번엔 Python 이라고 칩니다. 한국어 팩을 깔고 재시작했다면 패널 이름이 '확장: 마켓플레이스'로 바뀌어 있을 겁니다.</a:t>
             </a:r>
           </a:p>
           <a:p/>
           <a:p>
             <a:r>
               <a:rPr lang="ko-KR"/>
-              <a:t>⑤번. 결과 맨 위에 "Python", 제작자 Microsoft, 다운로드 2억 3천만 회짜리가 나옵니다. 오른쪽 설명처럼 비슷한 이름이 여러 개 나옵니다. Python Debugger, Python Indent, Python Preview 등등. 그중 제작자가 Microsoft이고 파란 체크 표시가 있는, 이름이 딱 "Python"인 맨 위 항목이 정답입니다. 그 항목의 파란 Install 버튼을 누릅니다. 이걸 깔면 'Python Debugger'와 'Pylance'라는 확장이 자동으로 함께 설치되는데, 정상입니다. 세 개가 한 세트입니다.</a:t>
+              <a:t>5번. 결과 맨 위에 "Python", 제작자 Microsoft, 다운로드 2억 3천만 회짜리가 나옵니다. 오른쪽 설명처럼 비슷한 이름이 여러 개 나옵니다. Python Debugger, Python Indent, Python Preview 등등. 그중 제작자가 Microsoft이고 파란 체크 표시가 있는, 이름이 딱 "Python"인 맨 위 항목이 정답입니다. 그 항목의 파란 Install 버튼을 누릅니다. 이걸 깔면 'Python Debugger'와 'Pylance'라는 확장이 자동으로 함께 설치되는데, 정상입니다. 세 개가 한 세트입니다.</a:t>
             </a:r>
           </a:p>
           <a:p/>
           <a:p>
             <a:r>
               <a:rPr lang="ko-KR"/>
-              <a:t>⑥번. 설치는 10~30초 걸립니다. 파란 Install 버튼이 톱니바퀴 아이콘으로 바뀌면 설치 완료입니다. 확인하려면 확장 패널의 검색창을 비워 보세요. 그러면 '설치됨(INSTALLED)' 목록이 보이는데, 거기에 Korean Language Pack과 Python이 있으면 됩니다.</a:t>
+              <a:t>6번. 설치는 10에서 30초 걸립니다. 파란 Install 버튼이 톱니바퀴 아이콘으로 바뀌면 설치 완료입니다. 확인하려면 확장 패널의 검색창을 비워 보세요. 그러면 '설치됨(INSTALLED)' 목록이 보이는데, 거기에 Korean Language Pack과 Python이 있으면 됩니다.</a:t>
             </a:r>
           </a:p>
           <a:p/>
           <a:p>
             <a:r>
               <a:rPr lang="ko-KR"/>
-              <a:t>오른쪽 아래 작은 화면은 나중에 볼 알림입니다. 파이썬 파일, 그러니까 .py로 끝나는 파일을 열었을 때 "Python 확장을 설치할까요?"라는 알림이 뜨는 경우가 있습니다. 이미 깔았으면 안 뜨고, 혹시 뜨면 그냥 Install을 누르면 됩니다.</a:t>
+              <a:t>오른쪽 아래 작은 화면은 나중에 볼 알림입니다. 파이썬 파일, 그러니까.py로 끝나는 파일을 열었을 때 "Python 확장을 설치할까요?"라는 알림이 뜨는 경우가 있습니다. 이미 깔았으면 안 뜨고, 혹시 뜨면 그냥 Install을 누르면 됩니다.</a:t>
             </a:r>
           </a:p>
           <a:p/>
           <a:p>
             <a:r>
               <a:rPr lang="ko-KR"/>
-              <a:t>아래 초록 박스가 이 단계 통과 기준입니다. VS Code 메뉴가 한국어로 보이고, 확장 아이콘을 눌렀을 때 '설치됨' 목록에 두 개가 있다. 둘 다 되면 손 들어서 확인받고 다음으로 갑니다.</a:t>
+              <a:t>아래 초록 박스가 이 단계 통과 기준입니다. VS Code 메뉴가 한국어로 보이고, 확장 아이콘을 눌렀을 때 '설치됨' 목록에 두 개가 있다. 둘 다 되면 다음으로 갑니다.</a:t>
             </a:r>
           </a:p>
           <a:p/>
           <a:p>
             <a:r>
               <a:rPr lang="ko-KR"/>
-              <a:t>(여기까지가 대략 절반입니다. 진도가 늦으면 5분 쉬고 갑니다.)</a:t>
+              <a:t>여기까지가 대략 절반입니다.</a:t>
             </a:r>
           </a:p>
         </p:txBody>
@@ -3526,21 +3484,21 @@
           <a:p>
             <a:r>
               <a:rPr lang="ko-KR"/>
-              <a:t>①번. 브라우저 주소창에 git-scm.com 을 입력합니다. 페이지 왼쪽 메뉴에 About, Learn, Tools, Reference, Install, Community가 있는데 'Install'을 클릭합니다. 그러면 왼쪽 화면처럼 Windows · macOS · Linux 탭이 있는 설치 페이지가 나옵니다. Windows 탭이 선택돼 있는지 확인하세요. 주소창에 바로 git-scm.com/install/windows 를 쳐도 같은 곳으로 갑니다.</a:t>
+              <a:t>1번. 브라우저 주소창에 git-scm.com 을 입력합니다. 페이지 왼쪽 메뉴에 About, Learn, Tools, Reference, Install, Community가 있는데 'Install'을 클릭합니다. 그러면 왼쪽 화면처럼 Windows, macOS, Linux 탭이 있는 설치 페이지가 나옵니다. Windows 탭이 선택돼 있는지 확인하세요. 주소창에 바로 git-scm.com/install/windows 를 쳐도 같은 곳으로 갑니다.</a:t>
             </a:r>
           </a:p>
           <a:p/>
           <a:p>
             <a:r>
               <a:rPr lang="ko-KR"/>
-              <a:t>②번. 첫 줄에 파란 글씨로 "Click here to download"가 있습니다. 슬라이드 빨간 네모 ②번입니다. 그 뒤에 "the latest (2.55.0) x64 version of Git for Windows"라고 이어지죠. 여기서 x64는 64비트라는 뜻이고, 요즘 노트북은 거의 전부 64비트라 이걸 받으면 됩니다. 클릭하면 Git-2.55.0-64-bit.exe 같은 파일이 내려받아집니다. 숫자는 날짜에 따라 다릅니다. Mac 사용자는 macOS 탭을 보거나, 더 간단하게는 터미널에 git 이라고 쳐 보세요. 없으면 설치하겠냐는 안내가 자동으로 뜹니다.</a:t>
+              <a:t>2번. 첫 줄에 파란 글씨로 "Click here to download"가 있습니다. 슬라이드 빨간 네모 2번입니다. 그 뒤에 "the latest (2.55.0) x64 version of Git for Windows"라고 이어지죠. 여기서 x64는 64비트라는 뜻이고, 요즘 노트북은 거의 전부 64비트라 이걸 받으면 됩니다. 클릭하면 Git-2.55.0-64-bit.exe 같은 파일이 내려받아집니다. 숫자는 날짜에 따라 다릅니다. Mac 사용자는 macOS 탭을 보거나, 더 간단하게는 터미널에 git 이라고 쳐 보세요. 없으면 설치하겠냐는 안내가 자동으로 뜹니다.</a:t>
             </a:r>
           </a:p>
           <a:p/>
           <a:p>
             <a:r>
               <a:rPr lang="ko-KR"/>
-              <a:t>③번. 받은 파일을 실행하면 설치 화면이 뜨는데, 이게 좀 깁니다. 에디터 선택, 브랜치 이름, PATH 조정, 줄바꿈 처리, 터미널 종류… 낯선 단어가 가득한 화면이 열 개 넘게 이어집니다. 하나도 바꾸지 말고 전부 Next를 누르세요. 마지막에 Install, 그리고 Finish. 이 옵션들은 나중에 언제든 바꿀 수 있고, 기본값이 이 수업에 가장 잘 맞습니다. Finish 화면에 "View Release Notes" 체크가 있으면 꺼도 됩니다.</a:t>
+              <a:t>3번. 받은 파일을 실행하면 설치 화면이 뜨는데, 이게 좀 깁니다. 에디터 선택, 브랜치 이름, PATH 조정, 줄바꿈 처리, 터미널 종류… 낯선 단어가 가득한 화면이 열 개 넘게 이어집니다. 하나도 바꾸지 말고 전부 Next를 누르세요. 마지막에 Install, 그리고 Finish. 이 옵션들은 나중에 언제든 바꿀 수 있고, 기본값이 이 수업에 가장 잘 맞습니다. Finish 화면에 "View Release Notes" 체크가 있으면 꺼도 됩니다.</a:t>
             </a:r>
           </a:p>
           <a:p/>
@@ -3554,7 +3512,7 @@
           <a:p>
             <a:r>
               <a:rPr lang="ko-KR"/>
-              <a:t>(다운로드 1분, 설치 2~3분. Next를 계속 누르는 동안 교실을 돕니다.)</a:t>
+              <a:t>다운로드 1분, 설치 2, 3분 정도 걸립니다.</a:t>
             </a:r>
           </a:p>
         </p:txBody>
@@ -3632,7 +3590,7 @@
           <a:p>
             <a:r>
               <a:rPr lang="ko-KR"/>
-              <a:t>먼저 VS Code에서 터미널 여는 법, 왼쪽 위 화면입니다. ①번 메뉴에서 ②번 '터미널(Terminal)'을 누르고 ③번 '새 터미널(New Terminal)'을 누릅니다. 슬라이드 그림은 창이 좁을 때 나오는 줄 세 개짜리 메뉴 아이콘 화면이고, 여러분 PC 설치판은 창 위쪽에 '파일 편집 선택 영역 보기 이동 실행 터미널 도움말' 메뉴가 바로 보이니까 거기서 '터미널'을 누르면 됩니다. 단축키는 Ctrl+백틱입니다. 백틱은 키보드 왼쪽 위, 숫자 1 왼쪽에 있는 ` 키입니다. 물결(~)이랑 같이 있는 키요. 누르면 왼쪽 아래 화면처럼 VS Code 창 아래쪽에 터미널 패널이 열립니다. 여기가 이제부터 우리의 터미널입니다.</a:t>
+              <a:t>먼저 VS Code에서 터미널 여는 법, 왼쪽 위 화면입니다. 1번 메뉴에서 2번 '터미널(Terminal)'을 누르고 3번 '새 터미널(New Terminal)'을 누릅니다. 슬라이드 그림은 창이 좁을 때 나오는 줄 세 개짜리 메뉴 아이콘 화면이고, 여러분 PC 설치판은 창 위쪽에 '파일 편집 선택 영역 보기 이동 실행 터미널 도움말' 메뉴가 바로 보이니까 거기서 '터미널'을 누르면 됩니다. 단축키는 Ctrl+백틱입니다. 백틱은 키보드 왼쪽 위, 숫자 1 왼쪽에 있는 ` 키입니다. 물결(~)이랑 같이 있는 키요. 누르면 왼쪽 아래 화면처럼 VS Code 창 아래쪽에 터미널 패널이 열립니다. 여기가 이제부터 우리의 터미널입니다.</a:t>
             </a:r>
           </a:p>
           <a:p/>
@@ -3674,14 +3632,7 @@
           <a:p>
             <a:r>
               <a:rPr lang="ko-KR"/>
-              <a:t>오른쪽 분홍 박스, 자주 나는 문제. "'git'은(는) 내부 또는 외부 명령… 이 아닙니다"라고 나오면, Git 설치 전에 켜 둔 VS Code가 새 프로그램을 몰라서 그렇습니다. VS Code를 완전히 끄고(창 닫기) 다시 켠 뒤 새 터미널에서 다시 치세요. 그래도 안 되면 손 드세요.</a:t>
-            </a:r>
-          </a:p>
-          <a:p/>
-          <a:p>
-            <a:r>
-              <a:rPr lang="ko-KR"/>
-              <a:t>(전원 git --version 확인 후 다음으로.)</a:t>
+              <a:t>오른쪽 분홍 박스, 자주 나는 문제. "'git'은(는) 내부 또는 외부 명령… 이 아닙니다"라고 나오면, Git 설치 전에 켜 둔 VS Code가 새 프로그램을 몰라서 그렇습니다. VS Code를 완전히 끄고(창 닫기) 다시 켠 뒤 새 터미널에서 다시 치세요. 그래도 안 되면 질문하세요.</a:t>
             </a:r>
           </a:p>
         </p:txBody>
@@ -3759,21 +3710,21 @@
           <a:p>
             <a:r>
               <a:rPr lang="ko-KR"/>
-              <a:t>①번. 브라우저에서 github.com 에 들어가면 왼쪽 화면이 나옵니다. 오른쪽 위에 "Sign in"과 "Sign up"이 있는데, Sign up이 가입입니다. 화면 가운데 이메일 칸에 주소를 넣고 초록 "Sign up for GitHub"를 눌러도 같은 절차로 갑니다. 가입 화면은 이메일 → 비밀번호 → 아이디(Username) → 국가 순서로 입력하고 Continue를 누릅니다. 비밀번호는 15자 이상이거나, 8자 이상에 숫자와 소문자를 섞어야 통과됩니다.</a:t>
+              <a:t>1번. 브라우저에서 github.com 에 들어가면 왼쪽 화면이 나옵니다. 오른쪽 위에 "Sign in"과 "Sign up"이 있는데, Sign up이 가입입니다. 화면 가운데 이메일 칸에 주소를 넣고 초록 "Sign up for GitHub"를 눌러도 같은 절차로 갑니다. 가입 화면은 이메일, 비밀번호, 아이디(Username), 국가 순서로 입력하고 Continue를 누릅니다. 비밀번호는 15자 이상이거나, 8자 이상에 숫자와 소문자를 섞어야 통과됩니다.</a:t>
             </a:r>
           </a:p>
           <a:p/>
           <a:p>
             <a:r>
               <a:rPr lang="ko-KR"/>
-              <a:t>②번. 이메일은 아까 Git에 등록한 그 주소로 하세요. 학교 이메일을 권합니다. 이유는 두 가지인데, Git 서명과 맞춰야 기록이 연결되고, 다음 장에 나올 학생 혜택 인증에도 학교 이메일이 쓰이기 때문입니다. 중간에 "사람인지 확인합니다"라는 퍼즐이 나올 수 있는데 그건 로봇 가입을 막는 것이니 풀어 주세요. 마지막에 그 이메일로 8자리 인증 코드가 오는데, 그걸 입력하면 가입 완료입니다. 이메일이 안 오면 스팸함을 확인하세요.</a:t>
+              <a:t>2번. 이메일은 아까 Git에 등록한 그 주소로 하세요. 학교 이메일을 권합니다. 이유는 두 가지인데, Git 서명과 맞춰야 기록이 연결되고, 다음 장에 나올 학생 혜택 인증에도 학교 이메일이 쓰이기 때문입니다. 중간에 "사람인지 확인합니다"라는 퍼즐이 나올 수 있는데 그건 로봇 가입을 막는 것이니 풀어 주세요. 마지막에 그 이메일로 8자리 인증 코드가 오는데, 그걸 입력하면 가입 완료입니다. 이메일이 안 오면 스팸함을 확인하세요.</a:t>
             </a:r>
           </a:p>
           <a:p/>
           <a:p>
             <a:r>
               <a:rPr lang="ko-KR"/>
-              <a:t>③번. 가입이 끝나고 로그인된 첫 화면이 보이면 이 단계 통과입니다. 이 화면을 '대시보드'라고 부르는데, 왼쪽에 "Top repositories", 오른쪽 위에 + 버튼과 내 프로필 사진이 보입니다. 처음엔 안내 화면이 몇 개 나올 수 있는데 건너뛰어도 됩니다.</a:t>
+              <a:t>3번. 가입이 끝나고 로그인된 첫 화면이 보이면 이 단계 통과입니다. 이 화면을 '대시보드'라고 부르는데, 왼쪽에 "Top repositories", 오른쪽 위에 + 버튼과 내 프로필 사진이 보입니다. 처음엔 안내 화면이 몇 개 나올 수 있는데 건너뛰어도 됩니다.</a:t>
             </a:r>
           </a:p>
           <a:p/>
@@ -3787,7 +3738,7 @@
           <a:p>
             <a:r>
               <a:rPr lang="ko-KR"/>
-              <a:t>(가입에 3~5분. 이메일 인증이 늦는 사람은 기다리는 동안 다음 장을 먼저 봅니다.)</a:t>
+              <a:t>가입에 3분에서 5분 정도 걸립니다. 이메일 인증이 늦으면 기다리는 동안 다음 장을 먼저 봐도 됩니다.</a:t>
             </a:r>
           </a:p>
         </p:txBody>
@@ -3879,7 +3830,7 @@
           <a:p>
             <a:r>
               <a:rPr lang="ko-KR"/>
-              <a:t>신청 방법은 간단합니다. GitHub에 로그인한 상태로 이 주소에 들어가서 초록 버튼 "Sign up for Student Developer Pack"을 누르고, 학교 이메일을 인증하고, 학생증이나 재학증명서 사진을 올리면 됩니다. 며칠 안에 승인 메일이 옵니다. 신청 자체는 5분, 승인은 보통 1~7일입니다.</a:t>
+              <a:t>신청 방법은 간단합니다. GitHub에 로그인한 상태로 이 주소에 들어가서 초록 버튼 "Sign up for Student Developer Pack"을 누르고, 학교 이메일을 인증하고, 학생증이나 재학증명서 사진을 올리면 됩니다. 며칠 안에 승인 메일이 옵니다. 신청 자체는 5분, 승인은 보통 1에서 7일입니다.</a:t>
             </a:r>
           </a:p>
           <a:p/>
@@ -3978,21 +3929,21 @@
           <a:p>
             <a:r>
               <a:rPr lang="ko-KR"/>
-              <a:t>①번, ②번. 왼쪽 위 그림입니다. GitHub 어느 페이지에서든 오른쪽 위에 + 모양 버튼이 있습니다. 누르면 메뉴가 펼쳐지고 맨 위에 "New repository"가 있습니다. 클릭. 이 그림은 GitHub 공식 문서에서 가져온 것이라 여러분 화면과 아이콘 배치가 거의 같습니다.</a:t>
+              <a:t>1번, 2번. 왼쪽 위 그림입니다. GitHub 어느 페이지에서든 오른쪽 위에 + 모양 버튼이 있습니다. 누르면 메뉴가 펼쳐지고 맨 위에 "New repository"가 있습니다. 클릭. 이 그림은 GitHub 공식 문서에서 가져온 것이라 여러분 화면과 아이콘 배치가 거의 같습니다.</a:t>
             </a:r>
           </a:p>
           <a:p/>
           <a:p>
             <a:r>
               <a:rPr lang="ko-KR"/>
-              <a:t>③번. 새 저장소 만들기 화면이 나옵니다. 위쪽 "General" 부분에 Owner와 Repository name이 있는데, Owner는 본인 아이디가 자동으로 들어가 있고, Repository name 칸에 이름을 씁니다. 오늘은 다 같이 hello-sw 로 통일합니다. h-e-l-l-o, 하이픈, s-w. 저장소 이름은 영문 소문자와 하이픈만 쓰는 게 관례입니다. 띄어쓰기나 한글은 피하세요. 이름 아래에 초록 체크와 "hello-sw is available"이 뜨면 쓸 수 있는 이름입니다.</a:t>
+              <a:t>3번. 새 저장소 만들기 화면이 나옵니다. 위쪽 "General" 부분에 Owner와 Repository name이 있는데, Owner는 본인 아이디가 자동으로 들어가 있고, Repository name 칸에 이름을 씁니다. 오늘은 다 같이 hello-sw 로 통일합니다. h-e-l-l-o, 하이픈, s-w. 저장소 이름은 영문 소문자와 하이픈만 쓰는 게 관례입니다. 띄어쓰기나 한글은 피하세요. 이름 아래에 초록 체크와 "hello-sw is available"이 뜨면 쓸 수 있는 이름입니다.</a:t>
             </a:r>
           </a:p>
           <a:p/>
           <a:p>
             <a:r>
               <a:rPr lang="ko-KR"/>
-              <a:t>같은 화면을 아래로 내리면 옵션이 있는데, 가운데 흰 카드에 요약해 뒀습니다. ④번, Public과 Private 중 Public을 고릅니다. Public은 누구나 볼 수 있는 공개 저장소, Private은 나만 보는 비공개입니다. 과제 확인을 위해 Public으로 통일합니다. ⑤번, "Add a README file" 체크박스를 켭니다. README는 '이 저장소가 뭔지' 적어 두는 설명 파일인데, 이걸 켜야 파일이 하나 들어간 상태로 저장소가 시작됩니다. 왜 그게 중요하냐면, 빈 저장소는 내 컴퓨터로 내려받을 때 절차가 조금 더 복잡해서, 파일이 하나라도 있는 상태로 시작해야 다음 장에서 바로 내려받아 작업할 수 있기 때문입니다. .gitignore와 License는 건드리지 않습니다. ⑥번, 맨 아래 초록 "Create repository" 버튼을 누릅니다.</a:t>
+              <a:t>같은 화면을 아래로 내리면 옵션이 있는데, 가운데 흰 카드에 요약해 뒀습니다. 4번, Public과 Private 중 Public을 고릅니다. Public은 누구나 볼 수 있는 공개 저장소, Private은 나만 보는 비공개입니다. 과제 확인을 위해 Public으로 통일합니다. 5번, "Add a README file" 체크박스를 켭니다. README는 '이 저장소가 뭔지' 적어 두는 설명 파일인데, 이걸 켜야 파일이 하나 들어간 상태로 저장소가 시작됩니다. 왜 그게 중요하냐면, 빈 저장소는 내 컴퓨터로 내려받을 때 절차가 조금 더 복잡해서, 파일이 하나라도 있는 상태로 시작해야 다음 장에서 바로 내려받아 작업할 수 있기 때문입니다..gitignore와 License는 건드리지 않습니다. 6번, 맨 아래 초록 "Create repository" 버튼을 누릅니다.</a:t>
             </a:r>
           </a:p>
           <a:p/>
@@ -4013,7 +3964,7 @@
           <a:p>
             <a:r>
               <a:rPr lang="ko-KR"/>
-              <a:t>(1~2분. Private으로 만든 사람이 있으면 Settings에서 바꿀 수 있지만, 그냥 삭제하고 다시 만드는 게 빠릅니다.)</a:t>
+              <a:t>Private으로 만들었다면 Settings에서 바꿀 수도 있지만, 그냥 삭제하고 다시 만드는 게 빠릅니다.</a:t>
             </a:r>
           </a:p>
         </p:txBody>
@@ -4098,14 +4049,14 @@
           <a:p>
             <a:r>
               <a:rPr lang="ko-KR"/>
-              <a:t>①번. 저장소 페이지 오른쪽 위, 파일 목록 바로 위에 초록 "Code" 버튼이 있습니다. 클릭하면 작은 창이 펼쳐집니다.</a:t>
+              <a:t>1번. 저장소 페이지 오른쪽 위, 파일 목록 바로 위에 초록 "Code" 버튼이 있습니다. 클릭하면 작은 창이 펼쳐집니다.</a:t>
             </a:r>
           </a:p>
           <a:p/>
           <a:p>
             <a:r>
               <a:rPr lang="ko-KR"/>
-              <a:t>②번. 펼쳐진 창에 "Clone"이라고 쓰여 있고, HTTPS와 GitHub CLI 탭이 있습니다. HTTPS 탭이 선택된 상태에서 그 아래 주소가 보입니다. https://github.com/아이디/hello-sw.git 형태입니다. 주소 오른쪽 끝의 네모 두 개 겹친 아이콘이 '복사' 버튼입니다. 그걸 누르면 주소가 복사됩니다. 혹시 SSH라는 탭이 보여도 그건 고르지 마세요. 오늘은 HTTPS입니다.</a:t>
+              <a:t>2번. 펼쳐진 창에 "Clone"이라고 쓰여 있고, HTTPS와 GitHub CLI 탭이 있습니다. HTTPS 탭이 선택된 상태에서 그 아래 주소가 보입니다. https://github.com/아이디/hello-sw.git 형태입니다. 주소 오른쪽 끝의 네모 두 개 겹친 아이콘이 '복사' 버튼입니다. 그걸 누르면 주소가 복사됩니다. 혹시 SSH라는 탭이 보여도 그건 고르지 마세요. 오늘은 HTTPS입니다.</a:t>
             </a:r>
           </a:p>
           <a:p/>
@@ -4126,14 +4077,14 @@
           <a:p>
             <a:r>
               <a:rPr lang="ko-KR"/>
-              <a:t>그리고 이제 VS Code에서 그 폴더를 엽니다. 메뉴 [파일 → 폴더 열기]에서 방금 생긴 hello-sw 폴더를 선택하면, VS Code 왼쪽 탐색기에 README.md가 보입니다. "이 폴더의 작성자를 신뢰합니까?"라는 창이 뜨면 '예, 작성자를 신뢰합니다'를 누르세요. 여러분이 만든 폴더니까요.</a:t>
+              <a:t>그리고 이제 VS Code에서 그 폴더를 엽니다. 메뉴 [파일, 폴더 열기]에서 방금 생긴 hello-sw 폴더를 선택하면, VS Code 왼쪽 탐색기에 README.md가 보입니다. "이 폴더의 작성자를 신뢰합니까?"라는 창이 뜨면 '예, 작성자를 신뢰합니다'를 누르세요. 여러분이 만든 폴더니까요.</a:t>
             </a:r>
           </a:p>
           <a:p/>
           <a:p>
             <a:r>
               <a:rPr lang="ko-KR"/>
-              <a:t>(clone이 실패하는 경우: 주소를 잘못 붙여넣었거나, 인터넷 문제입니다. 주소를 다시 복사해서 시도하게 합니다.)</a:t>
+              <a:t>clone이 실패하면 주소를 잘못 붙여넣었거나 인터넷 문제입니다. 주소를 다시 복사해서 시도하세요.</a:t>
             </a:r>
           </a:p>
         </p:txBody>
@@ -4211,21 +4162,21 @@
           <a:p>
             <a:r>
               <a:rPr lang="ko-KR"/>
-              <a:t>①번. VS Code에서 hello-sw 폴더가 열려 있어야 합니다. 방금 안 열었으면 메뉴 [파일 → 폴더 열기]로 여세요.</a:t>
+              <a:t>1번. VS Code에서 hello-sw 폴더가 열려 있어야 합니다. 방금 안 열었으면 메뉴 [파일, 폴더 열기]로 여세요.</a:t>
             </a:r>
           </a:p>
           <a:p/>
           <a:p>
             <a:r>
               <a:rPr lang="ko-KR"/>
-              <a:t>②번. 왼쪽 탐색기에서 폴더 이름 HELLO-SW 위에 마우스를 올리면 오른쪽에 작은 아이콘 네 개가 나타나는데, 첫 번째가 '새 파일'입니다. 그걸 누르면 이름을 쓰는 칸이 생깁니다. hello.py 라고 치고 Enter. 마지막이 점 p y 입니다. 이 확장자가 "파이썬 파일"이라는 표시입니다. 그러면 왼쪽 그림처럼 탐색기에 hello.py가 생기고 오른쪽 편집기에 빈 파일이 열립니다. 아이콘을 못 찾겠으면 메뉴 [파일 → 새 텍스트 파일]로 만들고 저장할 때 이름을 hello.py로 하면 됩니다.</a:t>
+              <a:t>2번. 왼쪽 탐색기에서 폴더 이름 HELLO-SW 위에 마우스를 올리면 오른쪽에 작은 아이콘 네 개가 나타나는데, 첫 번째가 '새 파일'입니다. 그걸 누르면 이름을 쓰는 칸이 생깁니다. hello.py 라고 치고 Enter. 마지막이 점 p y 입니다. 이 확장자가 "파이썬 파일"이라는 표시입니다. 그러면 왼쪽 그림처럼 탐색기에 hello.py가 생기고 오른쪽 편집기에 빈 파일이 열립니다. 아이콘을 못 찾겠으면 메뉴 [파일, 새 텍스트 파일]로 만들고 저장할 때 이름을 hello.py로 하면 됩니다.</a:t>
             </a:r>
           </a:p>
           <a:p/>
           <a:p>
             <a:r>
               <a:rPr lang="ko-KR"/>
-              <a:t>③번. 편집기에 딱 한 줄을 칩니다. 아래 그림에 있는 그대로입니다. print, 소괄호 열고, 큰따옴표, Hello, Software Engineering, 큰따옴표 닫고, 소괄호 닫고. print는 "화면에 글자를 보여 줘"라는 파이썬 명령입니다. 다 쳤으면 Ctrl+S로 저장합니다. 저장하면 탭 이름 옆의 하얀 동그라미가 사라집니다. 하얀 동그라미는 '아직 저장 안 됨' 표시입니다.</a:t>
+              <a:t>3번. 편집기에 딱 한 줄을 칩니다. 아래 그림에 있는 그대로입니다. print, 소괄호 열고, 큰따옴표, Hello, Software Engineering, 큰따옴표 닫고, 소괄호 닫고. print는 "화면에 글자를 보여 줘"라는 파이썬 명령입니다. 다 쳤으면 Ctrl+S로 저장합니다. 저장하면 탭 이름 옆의 하얀 동그라미가 사라집니다. 하얀 동그라미는 '아직 저장 안 됨' 표시입니다.</a:t>
             </a:r>
           </a:p>
           <a:p/>
@@ -4274,7 +4225,7 @@
           <a:p>
             <a:r>
               <a:rPr lang="ko-KR"/>
-              <a:t>(여기서 시간이 제일 많이 걸립니다. 순회하면서 add/commit/push 결과 메시지를 확인합니다. commit에서 "Please tell me who you are"가 나오면 아까 git config 단계를 안 한 것이니 그 슬라이드로 돌아갑니다.)</a:t>
+              <a:t>commit에서 "Please tell me who you are"라는 메시지가 나오면 아까 git config 단계를 안 한 것이니, 그 단계로 돌아가서 하면 됩니다.</a:t>
             </a:r>
           </a:p>
         </p:txBody>
@@ -4387,7 +4338,7 @@
           <a:p>
             <a:r>
               <a:rPr lang="ko-KR"/>
-              <a:t>(전원 완료할 때까지 순회합니다. 끝난 학생에게는 옆 사람 도와주기를 부탁합니다. 시간이 남으면 hello.py를 터미널에서 python hello.py 로 실행해 보게 합니다. 화면에 Hello, Software Engineering 이 찍히는 걸 보여 주면 좋습니다.)</a:t>
+              <a:t>시간이 남으면 hello.py를 터미널에서 python hello.py 로 실행해 보세요. 화면에 Hello, Software Engineering 이 찍히면 됩니다.</a:t>
             </a:r>
           </a:p>
         </p:txBody>
@@ -4507,14 +4458,7 @@
           <a:p>
             <a:r>
               <a:rPr lang="ko-KR"/>
-              <a:t>다섯 개 중 하나라도 안 되는 분은 지금 해결하고 가는 게 최선입니다. 집에 가면 다음 주까지 안 하게 되고, 다음 주 실습은 오늘 환경 위에서 바로 시작하기 때문입니다. 지금 안 되는 사람은 손 들어 주세요. 끝난 사람은 먼저 가도 되지만, 옆에서 도와주고 가면 더 좋습니다.</a:t>
-            </a:r>
-          </a:p>
-          <a:p/>
-          <a:p>
-            <a:r>
-              <a:rPr lang="ko-KR"/>
-              <a:t>(마무리 정리는 남은 사람들과 함께 5분 안에.)</a:t>
+              <a:t>다섯 개 중 하나라도 안 되는 분은 지금 해결하고 가는 게 최선입니다. 집에 가면 다음 주까지 안 하게 되고, 다음 주 실습은 오늘 환경 위에서 바로 시작하기 때문입니다. 지금 안 되는 부분이 있으면 질문으로 남겨 주세요. 다 된 사람은 옆 사람을 도와주면 더 좋습니다.</a:t>
             </a:r>
           </a:p>
         </p:txBody>

</xml_diff>

<commit_message>
docs: switch 1–3강 tool stack to Codex (ChatGPT free) + ZCode (shared Z.ai key)
- 2강 Part 3 rebuilt: ChatGPT 계정 → Codex 확장 설치/로그인 → ZCode 설치/공용 키 연결/첫 화면,
  키 보안, 첫 지시, 언제 뭘 쓰나, 잘 안 될 때, 체크리스트 (real screenshots: chatgpt.com,
  VS Code marketplace, zcode.z.ai, ZCode/Codex official docs)
- 1강 tool stack/preview and 3강 lab procedure/rules aligned; Gemini/Cline removed
- TTS-ready notes, 대본/ exports regenerated

Co-Authored-By: Claude Fable 5 <noreply@anthropic.com>
</commit_message>
<xml_diff>
--- a/data/생성형 AI 소프트웨어공학/생성형AI소프트웨어공학_1강.pptx
+++ b/data/생성형 AI 소프트웨어공학/생성형AI소프트웨어공학_1강.pptx
@@ -1011,21 +1011,21 @@
           <a:p>
             <a:r>
               <a:rPr lang="ko-KR"/>
-              <a:t>첫째, Google AI Studio. 구글이 만든 웹사이트인데, 여기서 AI 모델을 실험해 보고 'API 키'라는 것을 발급받습니다. API 키는 쉽게 말해 "내 프로그램이 구글의 AI를 불러 쓸 수 있게 해 주는 출입증"입니다. 2주차에 발급받습니다.</a:t>
+              <a:t>첫째, ChatGPT 계정. 무료 계정이면 됩니다. 다음 주에 쓸 Codex라는 도구가 이 계정으로 로그인하기 때문에 필요합니다. 이미 있는 분은 그대로 쓰고, 없는 분은 2주차 수업 시간에 같이 만듭니다.</a:t>
             </a:r>
           </a:p>
           <a:p/>
           <a:p>
             <a:r>
               <a:rPr lang="ko-KR"/>
-              <a:t>둘째, AI 엔진. Gemini는 구글의 생성형 AI 이름이고, API는 프로그램이 다른 프로그램을 불러 쓰는 통로입니다. 우리 수업에서 실제로 코드를 생성해 주는 엔진이 이것입니다. 엔진은 두 개를 씁니다. 하나는 여러분이 각자 무료로 발급받는 Gemini, 또 하나는 제가 구독해서 수업 시간에 나눠 쓰는 Z.ai의 GLM-5.3이라는 모델입니다. 집에서는 내 Gemini 키, 수업 시간에는 공용 Z.ai 키, 이렇게 씁니다. 둘 다 2주차에 연결합니다.</a:t>
+              <a:t>둘째, 코딩 에이전트 둘, Codex와 ZCode. 에이전트라는 건 "이 파일 만들어 줘, 저 기능 고쳐 줘"라고 말하면 실제로 내 컴퓨터의 파일을 만들고 고쳐 주는 AI를 말합니다. Codex는 OpenAI가 만든 것으로 VS Code 안에 들어오고, 여러분 ChatGPT 계정으로 씁니다. 두뇌는 GPT-5.6 모델입니다. ZCode는 중국 Z.ai라는 회사가 만든 별도 프로그램이고, 제가 구독해 둔 GLM-5.3이라는 모델을 수업 시간에 공용 키로 나눠 씁니다. 집에서는 Codex, 수업 시간에는 ZCode, 이렇게 씁니다. 둘 다 2주차에 연결합니다.</a:t>
             </a:r>
           </a:p>
           <a:p/>
           <a:p>
             <a:r>
               <a:rPr lang="ko-KR"/>
-              <a:t>셋째, VS Code와 Cline. VS Code는 코드를 편집하는 프로그램, 즉 개발자용 메모장이라고 보면 됩니다. 오늘 설치합니다. Cline은 VS Code 안에 끼워 넣는 확장 프로그램인데, "이 파일 만들어 줘, 저 기능 고쳐 줘"라고 말하면 실제로 내 컴퓨터의 파일을 만들고 고쳐 주는 '코딩 에이전트'입니다. 다음 주에 연결합니다.</a:t>
+              <a:t>셋째, VS Code. 코드를 편집하는 프로그램, 즉 개발자용 메모장이라고 보면 됩니다. 오늘 설치합니다. 다음 주에 Codex가 이 안에 확장으로 들어옵니다.</a:t>
             </a:r>
           </a:p>
           <a:p/>
@@ -1039,7 +1039,7 @@
           <a:p>
             <a:r>
               <a:rPr lang="ko-KR"/>
-              <a:t>비용 걱정하는 분들 계실 텐데, 무료 등급으로 수업 실습은 충분합니다. 신용카드 필요 없습니다. 자세한 건 다음 주에 다룹니다.</a:t>
+              <a:t>비용 걱정하는 분들 계실 텐데, ChatGPT 무료 계정과 수업 공용 키로 실습은 충분합니다. 신용카드 필요 없습니다. 자세한 건 다음 주에 다룹니다.</a:t>
             </a:r>
           </a:p>
         </p:txBody>
@@ -2691,7 +2691,7 @@
           <a:p>
             <a:r>
               <a:rPr lang="ko-KR"/>
-              <a:t>둘째, VS Code. 정식 이름은 Visual Studio Code, 마이크로소프트가 만든 무료 코드 편집기입니다. 한 학기 내내 쓸 작업대라고 생각하면 됩니다. 메모장과 비슷한데, 코드에 색을 입혀 주고, 파일을 정리해 주고, 안에 터미널도 들어 있습니다. 다음 주에 여기에 Cline이라는 AI 에이전트를 붙일 겁니다.</a:t>
+              <a:t>둘째, VS Code. 정식 이름은 Visual Studio Code, 마이크로소프트가 만든 무료 코드 편집기입니다. 한 학기 내내 쓸 작업대라고 생각하면 됩니다. 메모장과 비슷한데, 코드에 색을 입혀 주고, 파일을 정리해 주고, 안에 터미널도 들어 있습니다. 다음 주에 여기에 Codex라는 AI 에이전트를 붙일 겁니다.</a:t>
             </a:r>
           </a:p>
           <a:p/>
@@ -3173,7 +3173,7 @@
           <a:p>
             <a:r>
               <a:rPr lang="ko-KR"/>
-              <a:t>아래 박스는 '확장'이라는 개념입니다. VS Code는 처음엔 빈 작업대입니다. 필요한 공구를 '확장(Extension)'이라는 이름으로 끼워 넣는 구조입니다. 스마트폰에 앱을 깔아서 기능을 늘리는 것과 똑같습니다. 오늘은 딱 두 개만 설치합니다. 한국어 팩은 화면 메뉴를 한국어로 바꿔 주는 것이고, Python은 파이썬 코드에 색을 입히고 실행을 도와주는 것입니다. 그리고 다음 주에는 이 목록에 Cline이 추가됩니다. AI에게 지시하면 파일을 만들고 고쳐 주는 코딩 에이전트가 이 자리에 들어옵니다. 오늘은 자리만 만들어 두는 셈입니다.</a:t>
+              <a:t>아래 박스는 '확장'이라는 개념입니다. VS Code는 처음엔 빈 작업대입니다. 필요한 공구를 '확장(Extension)'이라는 이름으로 끼워 넣는 구조입니다. 스마트폰에 앱을 깔아서 기능을 늘리는 것과 똑같습니다. 오늘은 딱 두 개만 설치합니다. 한국어 팩은 화면 메뉴를 한국어로 바꿔 주는 것이고, Python은 파이썬 코드에 색을 입히고 실행을 도와주는 것입니다. 그리고 다음 주에는 이 목록에 Codex가 추가됩니다. AI에게 지시하면 파일을 만들고 고쳐 주는 코딩 에이전트가 이 자리에 들어옵니다. 오늘은 자리만 만들어 두는 셈입니다.</a:t>
             </a:r>
           </a:p>
           <a:p/>
@@ -4667,14 +4667,14 @@
           <a:p>
             <a:r>
               <a:rPr lang="ko-KR"/>
-              <a:t>뒷부분 실습에서는 드디어 AI를 연결합니다. Google AI Studio에서 Gemini API 키(AI를 불러 쓰는 출입증)를 발급받고, 그 키를 환경변수라는 안전한 방법으로 컴퓨터에 저장하고, VS Code에 Cline을 연결해서 첫 지시를 내려 봅니다. 엔진은 두 개를 연결합니다. 여러분 각자의 Gemini 키, 그리고 제가 수업 시간에 나눠 드리는 공용 Z.ai 키(GLM-5.3이라는 모델)입니다. 공용 키는 따로 준비할 게 없습니다. "hello.py를 고쳐서 내 이름을 출력하게 해 줘" 같은 지시를 하면 AI가 실제로 파일을 고치는 걸 보게 될 겁니다.</a:t>
+              <a:t>뒷부분 실습에서는 드디어 AI를 연결합니다. 에이전트 두 개를 붙입니다. 하나는 Codex, VS Code 안에 들어오는 OpenAI의 에이전트인데 여러분 ChatGPT 무료 계정으로 로그인하면 됩니다. 또 하나는 ZCode, 따로 설치하는 프로그램인데 제가 수업 시간에 나눠 드리는 공용 키로 연결합니다. 공용 키는 따로 준비할 게 없습니다. "hello.py를 고쳐서 내 이름을 출력하게 해 줘" 같은 지시를 하면 AI가 실제로 파일을 고치는 걸 보게 될 겁니다.</a:t>
             </a:r>
           </a:p>
           <a:p/>
           <a:p>
             <a:r>
               <a:rPr lang="ko-KR"/>
-              <a:t>준비물은 두 가지. 개인 구글 계정이 꼭 필요합니다. 학교 계정 말고 개인 지메일 계정이요. 없는 사람은 다음 주 전에 하나 만들어 오세요. 그리고 오늘 설치한 노트북 그대로 가져오시면 됩니다. 새로 설치할 것은 확장 하나뿐입니다.</a:t>
+              <a:t>준비물은 두 가지. ChatGPT 무료 계정이 필요합니다. chatgpt.com에서 구글 계정이나 이메일로 만들 수 있습니다. 없는 사람은 다음 주 전에 하나 만들어 오세요. 그리고 오늘 설치한 노트북 그대로 가져오시면 됩니다. 새로 설치할 것은 VS Code 확장 하나와 ZCode라는 프로그램 하나입니다.</a:t>
             </a:r>
           </a:p>
           <a:p/>
@@ -12809,7 +12809,7 @@
                 <a:ea typeface="Malgun Gothic" pitchFamily="34" charset="-122"/>
                 <a:cs typeface="Malgun Gothic" pitchFamily="34" charset="-120"/>
               </a:rPr>
-              <a:t>한 학기 내내 쓸 작업대(에디터). 다음 주에 AI 에이전트 Cline이 이 안에 들어옵니다.</a:t>
+              <a:t>한 학기 내내 쓸 작업대(에디터). 다음 주에 AI 에이전트 Codex가 이 안에 들어옵니다.</a:t>
             </a:r>
             <a:endParaRPr lang="en-US" sz="1100" dirty="0"/>
           </a:p>
@@ -19287,7 +19287,7 @@
                 <a:ea typeface="Malgun Gothic" pitchFamily="34" charset="-122"/>
                 <a:cs typeface="Malgun Gothic" pitchFamily="34" charset="-120"/>
               </a:rPr>
-              <a:t>VS Code는 처음엔 빈 작업대입니다. 필요한 공구를 '확장'으로 끼워 넣는 구조라서, 오늘은 한국어 팩(화면을 한국어로)과 Python(파이썬 코드 색칠·실행 도우미) 두 개만 설치합니다. 다음 주에는 이 목록에 Cline이 추가됩니다. AI에게 지시하면 파일을 만들고 고쳐 주는 코딩 에이전트가 이 자리에 들어옵니다.</a:t>
+              <a:t>VS Code는 처음엔 빈 작업대입니다. 필요한 공구를 '확장'으로 끼워 넣는 구조라서, 오늘은 한국어 팩(화면을 한국어로)과 Python(파이썬 코드 색칠·실행 도우미) 두 개만 설치합니다. 다음 주에는 이 목록에 Codex가 추가됩니다. AI에게 지시하면 파일을 만들고 고쳐 주는 코딩 에이전트가 이 자리에 들어옵니다.</a:t>
             </a:r>
           </a:p>
         </p:txBody>
@@ -32103,7 +32103,7 @@
                 <a:ea typeface="Malgun Gothic" pitchFamily="34" charset="-122"/>
                 <a:cs typeface="Malgun Gothic" pitchFamily="34" charset="-120"/>
               </a:rPr>
-              <a:t>Gemini API 키 발급 → 환경변수 설정 → VS Code에 Cline 연결(내 Gemini 키 + 수업 공용 Z.ai 키) → 첫 지시.</a:t>
+              <a:t>ChatGPT 계정 → VS Code에 Codex 로그인 → ZCode 설치·공용 키 연결 → 첫 지시.</a:t>
             </a:r>
             <a:endParaRPr lang="en-US" sz="1150" dirty="0"/>
           </a:p>
@@ -32210,7 +32210,7 @@
                 <a:ea typeface="Malgun Gothic" pitchFamily="34" charset="-122"/>
                 <a:cs typeface="Malgun Gothic" pitchFamily="34" charset="-120"/>
               </a:rPr>
-              <a:t>개인 구글 계정. API 키 발급에 필요합니다.</a:t>
+              <a:t>ChatGPT 무료 계정(chatgpt.com). 없으면 미리 만들어 오세요.</a:t>
             </a:r>
             <a:endParaRPr lang="en-US" sz="1200" dirty="0"/>
           </a:p>
@@ -32239,7 +32239,7 @@
                 <a:ea typeface="Malgun Gothic" pitchFamily="34" charset="-122"/>
                 <a:cs typeface="Malgun Gothic" pitchFamily="34" charset="-120"/>
               </a:rPr>
-              <a:t>오늘 설치한 환경 그대로의 노트북. 새로 설치할 것은 확장 하나뿐입니다.</a:t>
+              <a:t>오늘 설치한 환경 그대로의 노트북. 새로 설치할 것은 Codex 확장과 ZCode 프로그램입니다.</a:t>
             </a:r>
             <a:endParaRPr lang="en-US" sz="1200" dirty="0"/>
           </a:p>
@@ -33597,7 +33597,7 @@
                 <a:ea typeface="Malgun Gothic" pitchFamily="34" charset="-122"/>
                 <a:cs typeface="Malgun Gothic" pitchFamily="34" charset="-120"/>
               </a:rPr>
-              <a:t>Google AI Studio</a:t>
+              <a:t>ChatGPT 계정 (무료)</a:t>
             </a:r>
             <a:endParaRPr lang="en-US" sz="1300" dirty="0"/>
           </a:p>
@@ -33639,7 +33639,7 @@
                 <a:ea typeface="Malgun Gothic" pitchFamily="34" charset="-122"/>
                 <a:cs typeface="Malgun Gothic" pitchFamily="34" charset="-120"/>
               </a:rPr>
-              <a:t>모델을 실험하고 API 키를 발급받는 곳 (2주차)</a:t>
+              <a:t>Codex 로그인에 쓰는 내 계정. chatgpt.com 에서 무료 가입 (2주차)</a:t>
             </a:r>
             <a:endParaRPr lang="en-US" sz="1100" dirty="0"/>
           </a:p>
@@ -33726,7 +33726,7 @@
                 <a:ea typeface="Malgun Gothic" pitchFamily="34" charset="-122"/>
                 <a:cs typeface="Malgun Gothic" pitchFamily="34" charset="-120"/>
               </a:rPr>
-              <a:t>AI 엔진: Gemini API · Z.ai GLM-5.3</a:t>
+              <a:t>Codex · ZCode (코딩 에이전트)</a:t>
             </a:r>
             <a:endParaRPr lang="en-US" sz="1300" dirty="0"/>
           </a:p>
@@ -33768,7 +33768,7 @@
                 <a:ea typeface="Malgun Gothic" pitchFamily="34" charset="-122"/>
                 <a:cs typeface="Malgun Gothic" pitchFamily="34" charset="-120"/>
               </a:rPr>
-              <a:t>우리 수업의 엔진, 코드를 생성하는 생성형 AI. 내 Gemini 키 + 수업 공용 Z.ai 키 (2주차)</a:t>
+              <a:t>지시하면 파일을 만들고 고치는 AI 둘. Codex는 VS Code 확장(GPT-5.6), ZCode는 별도 앱(GLM-5.3, 수업 공용 키) (2주차)</a:t>
             </a:r>
             <a:endParaRPr lang="en-US" sz="1100" dirty="0"/>
           </a:p>
@@ -33855,7 +33855,7 @@
                 <a:ea typeface="Malgun Gothic" pitchFamily="34" charset="-122"/>
                 <a:cs typeface="Malgun Gothic" pitchFamily="34" charset="-120"/>
               </a:rPr>
-              <a:t>VS Code + Cline</a:t>
+              <a:t>VS Code</a:t>
             </a:r>
             <a:endParaRPr lang="en-US" sz="1300" dirty="0"/>
           </a:p>
@@ -33897,7 +33897,7 @@
                 <a:ea typeface="Malgun Gothic" pitchFamily="34" charset="-122"/>
                 <a:cs typeface="Malgun Gothic" pitchFamily="34" charset="-120"/>
               </a:rPr>
-              <a:t>에디터 속 코딩 에이전트. 지시하면 파일을 만들고 고침</a:t>
+              <a:t>한 학기 내내 쓸 작업대. 다음 주 Codex가 이 안에 들어옵니다 (오늘 설치)</a:t>
             </a:r>
             <a:endParaRPr lang="en-US" sz="1100" dirty="0"/>
           </a:p>

</xml_diff>

<commit_message>
docs: 1강/3강 wording for shared Z.ai account login in ZCode (instead of a shared key)
Co-Authored-By: Claude Fable 5 <noreply@anthropic.com>
</commit_message>
<xml_diff>
--- a/data/생성형 AI 소프트웨어공학/생성형AI소프트웨어공학_1강.pptx
+++ b/data/생성형 AI 소프트웨어공학/생성형AI소프트웨어공학_1강.pptx
@@ -1018,7 +1018,7 @@
           <a:p>
             <a:r>
               <a:rPr lang="ko-KR"/>
-              <a:t>둘째, 코딩 에이전트 둘, Codex와 ZCode. 에이전트라는 건 "이 파일 만들어 줘, 저 기능 고쳐 줘"라고 말하면 실제로 내 컴퓨터의 파일을 만들고 고쳐 주는 AI를 말합니다. Codex는 OpenAI가 만든 것으로 VS Code 안에 들어오고, 여러분 ChatGPT 계정으로 씁니다. 두뇌는 GPT-5.6 모델입니다. ZCode는 중국 Z.ai라는 회사가 만든 별도 프로그램이고, 제가 구독해 둔 GLM-5.3이라는 모델을 수업 시간에 공용 키로 나눠 씁니다. 집에서는 Codex, 수업 시간에는 ZCode, 이렇게 씁니다. 둘 다 2주차에 연결합니다.</a:t>
+              <a:t>둘째, 코딩 에이전트 둘, Codex와 ZCode. 에이전트라는 건 "이 파일 만들어 줘, 저 기능 고쳐 줘"라고 말하면 실제로 내 컴퓨터의 파일을 만들고 고쳐 주는 AI를 말합니다. Codex는 OpenAI가 만든 것으로 VS Code 안에 들어오고, 여러분 ChatGPT 계정으로 씁니다. 두뇌는 GPT-5.6 모델입니다. ZCode는 중국 Z.ai라는 회사가 만든 별도 프로그램이고, 제가 구독해 둔 GLM-5.3이라는 모델을 수업 시간에 제 계정으로 로그인해서 같이 씁니다. 집에서는 Codex, 수업 시간에는 ZCode, 이렇게 씁니다. 둘 다 2주차에 연결합니다.</a:t>
             </a:r>
           </a:p>
           <a:p/>
@@ -1039,7 +1039,7 @@
           <a:p>
             <a:r>
               <a:rPr lang="ko-KR"/>
-              <a:t>비용 걱정하는 분들 계실 텐데, ChatGPT 무료 계정과 수업 공용 키로 실습은 충분합니다. 신용카드 필요 없습니다. 자세한 건 다음 주에 다룹니다.</a:t>
+              <a:t>비용 걱정하는 분들 계실 텐데, ChatGPT 무료 계정과 수업 공용 계정으로 실습은 충분합니다. 신용카드 필요 없습니다. 자세한 건 다음 주에 다룹니다.</a:t>
             </a:r>
           </a:p>
         </p:txBody>
@@ -4667,7 +4667,7 @@
           <a:p>
             <a:r>
               <a:rPr lang="ko-KR"/>
-              <a:t>뒷부분 실습에서는 드디어 AI를 연결합니다. 에이전트 두 개를 붙입니다. 하나는 Codex, VS Code 안에 들어오는 OpenAI의 에이전트인데 여러분 ChatGPT 무료 계정으로 로그인하면 됩니다. 또 하나는 ZCode, 따로 설치하는 프로그램인데 제가 수업 시간에 나눠 드리는 공용 키로 연결합니다. 공용 키는 따로 준비할 게 없습니다. "hello.py를 고쳐서 내 이름을 출력하게 해 줘" 같은 지시를 하면 AI가 실제로 파일을 고치는 걸 보게 될 겁니다.</a:t>
+              <a:t>뒷부분 실습에서는 드디어 AI를 연결합니다. 에이전트 두 개를 붙입니다. 하나는 Codex, VS Code 안에 들어오는 OpenAI의 에이전트인데 여러분 ChatGPT 무료 계정으로 로그인하면 됩니다. 또 하나는 ZCode, 따로 설치하는 프로그램인데 제가 수업 시간에 제 계정으로 로그인해 드려서 연결합니다. 따로 준비할 게 없습니다. "hello.py를 고쳐서 내 이름을 출력하게 해 줘" 같은 지시를 하면 AI가 실제로 파일을 고치는 걸 보게 될 겁니다.</a:t>
             </a:r>
           </a:p>
           <a:p/>
@@ -32103,7 +32103,7 @@
                 <a:ea typeface="Malgun Gothic" pitchFamily="34" charset="-122"/>
                 <a:cs typeface="Malgun Gothic" pitchFamily="34" charset="-120"/>
               </a:rPr>
-              <a:t>ChatGPT 계정 → VS Code에 Codex 로그인 → ZCode 설치·공용 키 연결 → 첫 지시.</a:t>
+              <a:t>ChatGPT 계정 → VS Code에 Codex 로그인 → ZCode 설치·공용 계정 연결 → 첫 지시.</a:t>
             </a:r>
             <a:endParaRPr lang="en-US" sz="1150" dirty="0"/>
           </a:p>
@@ -32266,7 +32266,7 @@
                 <a:ea typeface="Malgun Gothic" pitchFamily="34" charset="-122"/>
                 <a:cs typeface="Malgun Gothic" pitchFamily="34" charset="-120"/>
               </a:rPr>
-              <a:t>Z.ai 공용 키는 수업 시간에 나눠 드립니다. 미리 준비할 건 없습니다.</a:t>
+              <a:t>ZCode용 Z.ai 공용 계정은 수업 시간에 교수님이 로그인해 드립니다. 미리 준비할 건 없습니다.</a:t>
             </a:r>
           </a:p>
         </p:txBody>
@@ -33768,7 +33768,7 @@
                 <a:ea typeface="Malgun Gothic" pitchFamily="34" charset="-122"/>
                 <a:cs typeface="Malgun Gothic" pitchFamily="34" charset="-120"/>
               </a:rPr>
-              <a:t>지시하면 파일을 만들고 고치는 AI 둘. Codex는 VS Code 확장(GPT-5.6), ZCode는 별도 앱(GLM-5.3, 수업 공용 키) (2주차)</a:t>
+              <a:t>지시하면 파일을 만들고 고치는 AI 둘. Codex는 VS Code 확장(GPT-5.6), ZCode는 별도 앱(GLM-5.3, 수업 공용 계정) (2주차)</a:t>
             </a:r>
             <a:endParaRPr lang="en-US" sz="1100" dirty="0"/>
           </a:p>

</xml_diff>